<commit_message>
Add final deliverables: presentation PPT, poster PPT, report content, physics audit
</commit_message>
<xml_diff>
--- a/[완성본] 2026년 산학프로젝트 최종보고 발표자료.pptx
+++ b/[완성본] 2026년 산학프로젝트 최종보고 발표자료.pptx
@@ -18,11 +18,6 @@
     <p:sldId id="266" r:id="rId9"/>
     <p:sldId id="294" r:id="rId10"/>
     <p:sldId id="268" r:id="rId11"/>
-    <p:sldId id="295" r:id="rId18"/>
-    <p:sldId id="296" r:id="rId19"/>
-    <p:sldId id="297" r:id="rId20"/>
-    <p:sldId id="298" r:id="rId21"/>
-    <p:sldId id="299" r:id="rId22"/>
   </p:sldIdLst>
   <p:sldSz cx="12192000" cy="6858000"/>
   <p:notesSz cx="6858000" cy="9144000"/>
@@ -7055,12 +7050,19 @@
           <a:bodyPr/>
           <a:lstStyle/>
           <a:p>
-            <a:pPr algn="r"/>
-            <a:r>
-              <a:rPr lang="ko-KR" altLang="en-US" dirty="0" err="1"/>
-              <a:t>팀명</a:t>
-            </a:r>
-            <a:endParaRPr lang="ko-KR" altLang="en-US" dirty="0"/>
+            <a:r>
+              <a:t>AI 기반 비대칭 S-Curve 궤적 최적화 및</a:t>
+            </a:r>
+          </a:p>
+          <a:p>
+            <a:r>
+              <a:t>인풋쉐이핑을 활용한 반도체 픽앤플레이스</a:t>
+            </a:r>
+          </a:p>
+          <a:p>
+            <a:r>
+              <a:t>갠트리 진동 억제 시스템</a:t>
+            </a:r>
           </a:p>
         </p:txBody>
       </p:sp>
@@ -7092,29 +7094,14 @@
           </a:bodyPr>
           <a:lstStyle/>
           <a:p>
-            <a:pPr marL="0" marR="0" indent="0" algn="ctr" fontAlgn="base" latinLnBrk="0">
-              <a:lnSpc>
-                <a:spcPct val="130000"/>
-              </a:lnSpc>
-              <a:spcBef>
-                <a:spcPts val="0"/>
-              </a:spcBef>
-              <a:spcAft>
-                <a:spcPts val="0"/>
-              </a:spcAft>
-            </a:pPr>
-            <a:r>
-              <a:rPr lang="ko-KR" altLang="en-US" sz="3500" kern="0" spc="0" dirty="0">
-                <a:effectLst/>
-                <a:latin typeface="+mj-lt"/>
-                <a:ea typeface="YD윤고딕 320" panose="02020603020101020101" pitchFamily="18" charset="-127"/>
-              </a:rPr>
-              <a:t>연구주제</a:t>
-            </a:r>
-            <a:endParaRPr lang="ko-KR" altLang="en-US" sz="3500" kern="0" spc="0" dirty="0">
-              <a:effectLst/>
-              <a:latin typeface="+mj-lt"/>
-            </a:endParaRPr>
+            <a:r>
+              <a:t>2026년 산학프로젝트 최종보고</a:t>
+            </a:r>
+          </a:p>
+          <a:p>
+            <a:r>
+              <a:t>디지털 트윈 시뮬레이션 기반 성능 검증</a:t>
+            </a:r>
           </a:p>
         </p:txBody>
       </p:sp>
@@ -7264,44 +7251,38 @@
           <a:chExt cx="0" cy="0"/>
         </a:xfrm>
       </p:grpSpPr>
-    </p:spTree>
-    <p:extLst>
-      <p:ext uri="{BB962C8B-B14F-4D97-AF65-F5344CB8AC3E}">
-        <p14:creationId xmlns:p14="http://schemas.microsoft.com/office/powerpoint/2010/main" val="4288557334"/>
-      </p:ext>
-    </p:extLst>
-  </p:cSld>
-  <p:clrMapOvr>
-    <a:masterClrMapping/>
-  </p:clrMapOvr>
-</p:sld>
-</file>
-
-<file path=ppt/slides/slide11.xml><?xml version="1.0" encoding="utf-8"?>
-<p:sld xmlns:a="http://schemas.openxmlformats.org/drawingml/2006/main" xmlns:p="http://schemas.openxmlformats.org/presentationml/2006/main" xmlns:r="http://schemas.openxmlformats.org/officeDocument/2006/relationships">
-  <p:cSld>
-    <p:spTree>
-      <p:nvGrpSpPr>
-        <p:cNvPr id="1" name=""/>
-        <p:cNvGrpSpPr/>
-        <p:nvPr/>
-      </p:nvGrpSpPr>
-      <p:grpSpPr/>
       <p:sp>
         <p:nvSpPr>
-          <p:cNvPr id="2" name="Content Placeholder 1"/>
-          <p:cNvSpPr>
-            <a:spLocks noGrp="1"/>
-          </p:cNvSpPr>
-          <p:nvPr>
-            <p:ph idx="1"/>
-          </p:nvPr>
+          <p:cNvPr id="2" name="TextBox 1"/>
+          <p:cNvSpPr txBox="1"/>
+          <p:nvPr/>
         </p:nvSpPr>
-        <p:spPr/>
+        <p:spPr>
+          <a:xfrm>
+            <a:off x="1080000" y="1800000"/>
+            <a:ext cx="7920000" cy="1440000"/>
+          </a:xfrm>
+          <a:prstGeom prst="rect">
+            <a:avLst/>
+          </a:prstGeom>
+          <a:noFill/>
+        </p:spPr>
         <p:txBody>
-          <a:bodyPr/>
+          <a:bodyPr wrap="square">
+            <a:spAutoFit/>
+          </a:bodyPr>
           <a:lstStyle/>
-          <a:p/>
+          <a:p>
+            <a:pPr algn="ctr"/>
+            <a:r>
+              <a:rPr sz="4400" b="1">
+                <a:solidFill>
+                  <a:srgbClr val="1F497D"/>
+                </a:solidFill>
+              </a:rPr>
+              <a:t>감사합니다</a:t>
+            </a:r>
+          </a:p>
         </p:txBody>
       </p:sp>
       <p:sp>
@@ -7312,8 +7293,8 @@
         </p:nvSpPr>
         <p:spPr>
           <a:xfrm>
-            <a:off x="635000" y="1270000"/>
-            <a:ext cx="10922000" cy="4953000"/>
+            <a:off x="1080000" y="3420000"/>
+            <a:ext cx="7920000" cy="720000"/>
           </a:xfrm>
           <a:prstGeom prst="rect">
             <a:avLst/>
@@ -7326,360 +7307,24 @@
           </a:bodyPr>
           <a:lstStyle/>
           <a:p>
-            <a:r>
-              <a:t>1. 연구 배경: 반도체 장비의 딜레마</a:t>
-            </a:r>
-          </a:p>
-          <a:p/>
-          <a:p>
-            <a:r>
-              <a:t>• 생산성(UPH) 향상을 위해 모터 속도 증가 필수</a:t>
-            </a:r>
-          </a:p>
-          <a:p>
-            <a:r>
-              <a:t>• 고속 이동 시 로봇 팔 끝단에 심각한 '잔류 진동(Residual Vibration)' 발생</a:t>
-            </a:r>
-          </a:p>
-          <a:p>
-            <a:r>
-              <a:t>• 진동이 멈출 때까지 기다려야 하는 '정착 시간(Settling Time)'이 길어지면 전체 공정 시간 증가</a:t>
+            <a:pPr algn="ctr"/>
+            <a:r>
+              <a:rPr sz="2800" b="0">
+                <a:solidFill>
+                  <a:srgbClr val="666666"/>
+                </a:solidFill>
+              </a:rPr>
+              <a:t>Q &amp; A</a:t>
             </a:r>
           </a:p>
         </p:txBody>
       </p:sp>
     </p:spTree>
-  </p:cSld>
-  <p:clrMapOvr>
-    <a:masterClrMapping/>
-  </p:clrMapOvr>
-</p:sld>
-</file>
-
-<file path=ppt/slides/slide12.xml><?xml version="1.0" encoding="utf-8"?>
-<p:sld xmlns:a="http://schemas.openxmlformats.org/drawingml/2006/main" xmlns:p="http://schemas.openxmlformats.org/presentationml/2006/main" xmlns:r="http://schemas.openxmlformats.org/officeDocument/2006/relationships">
-  <p:cSld>
-    <p:spTree>
-      <p:nvGrpSpPr>
-        <p:cNvPr id="1" name=""/>
-        <p:cNvGrpSpPr/>
-        <p:nvPr/>
-      </p:nvGrpSpPr>
-      <p:grpSpPr/>
-      <p:sp>
-        <p:nvSpPr>
-          <p:cNvPr id="2" name="Content Placeholder 1"/>
-          <p:cNvSpPr>
-            <a:spLocks noGrp="1"/>
-          </p:cNvSpPr>
-          <p:nvPr>
-            <p:ph idx="1"/>
-          </p:nvPr>
-        </p:nvSpPr>
-        <p:spPr/>
-        <p:txBody>
-          <a:bodyPr/>
-          <a:lstStyle/>
-          <a:p/>
-        </p:txBody>
-      </p:sp>
-      <p:sp>
-        <p:nvSpPr>
-          <p:cNvPr id="3" name="TextBox 2"/>
-          <p:cNvSpPr txBox="1"/>
-          <p:nvPr/>
-        </p:nvSpPr>
-        <p:spPr>
-          <a:xfrm>
-            <a:off x="635000" y="1270000"/>
-            <a:ext cx="10922000" cy="4953000"/>
-          </a:xfrm>
-          <a:prstGeom prst="rect">
-            <a:avLst/>
-          </a:prstGeom>
-          <a:noFill/>
-        </p:spPr>
-        <p:txBody>
-          <a:bodyPr wrap="square">
-            <a:spAutoFit/>
-          </a:bodyPr>
-          <a:lstStyle/>
-          <a:p>
-            <a:r>
-              <a:t>2. 핵심 솔루션 1: 비대칭 S-Curve 궤적</a:t>
-            </a:r>
-          </a:p>
-          <a:p/>
-          <a:p>
-            <a:r>
-              <a:t>• 기존 사다리꼴(Trapezoidal) 궤적: 가속도 불연속으로 큰 저크(Jerk) 발생</a:t>
-            </a:r>
-          </a:p>
-          <a:p>
-            <a:r>
-              <a:t>• AS-Curve (비대칭 S-Curve) 적용:</a:t>
-            </a:r>
-          </a:p>
-          <a:p>
-            <a:r>
-              <a:t>  - 가속 구간: 빠르게 도달</a:t>
-            </a:r>
-          </a:p>
-          <a:p>
-            <a:r>
-              <a:t>  - 감속 구간: 부드럽게 정지 (Beta, Gamma 파라미터 최적화)</a:t>
-            </a:r>
-          </a:p>
-          <a:p>
-            <a:r>
-              <a:t>• 물리적 충격량 최소화 입증</a:t>
-            </a:r>
-          </a:p>
-        </p:txBody>
-      </p:sp>
-    </p:spTree>
-  </p:cSld>
-  <p:clrMapOvr>
-    <a:masterClrMapping/>
-  </p:clrMapOvr>
-</p:sld>
-</file>
-
-<file path=ppt/slides/slide13.xml><?xml version="1.0" encoding="utf-8"?>
-<p:sld xmlns:a="http://schemas.openxmlformats.org/drawingml/2006/main" xmlns:p="http://schemas.openxmlformats.org/presentationml/2006/main" xmlns:r="http://schemas.openxmlformats.org/officeDocument/2006/relationships">
-  <p:cSld>
-    <p:spTree>
-      <p:nvGrpSpPr>
-        <p:cNvPr id="1" name=""/>
-        <p:cNvGrpSpPr/>
-        <p:nvPr/>
-      </p:nvGrpSpPr>
-      <p:grpSpPr/>
-      <p:sp>
-        <p:nvSpPr>
-          <p:cNvPr id="2" name="Content Placeholder 1"/>
-          <p:cNvSpPr>
-            <a:spLocks noGrp="1"/>
-          </p:cNvSpPr>
-          <p:nvPr>
-            <p:ph idx="1"/>
-          </p:nvPr>
-        </p:nvSpPr>
-        <p:spPr/>
-        <p:txBody>
-          <a:bodyPr/>
-          <a:lstStyle/>
-          <a:p/>
-        </p:txBody>
-      </p:sp>
-      <p:sp>
-        <p:nvSpPr>
-          <p:cNvPr id="3" name="TextBox 2"/>
-          <p:cNvSpPr txBox="1"/>
-          <p:nvPr/>
-        </p:nvSpPr>
-        <p:spPr>
-          <a:xfrm>
-            <a:off x="635000" y="1270000"/>
-            <a:ext cx="10922000" cy="4953000"/>
-          </a:xfrm>
-          <a:prstGeom prst="rect">
-            <a:avLst/>
-          </a:prstGeom>
-          <a:noFill/>
-        </p:spPr>
-        <p:txBody>
-          <a:bodyPr wrap="square">
-            <a:spAutoFit/>
-          </a:bodyPr>
-          <a:lstStyle/>
-          <a:p>
-            <a:r>
-              <a:t>3. 핵심 솔루션 2: Input Shaping 제어</a:t>
-            </a:r>
-          </a:p>
-          <a:p/>
-          <a:p>
-            <a:r>
-              <a:t>• 파동의 상쇄 간섭 원리 활용</a:t>
-            </a:r>
-          </a:p>
-          <a:p>
-            <a:r>
-              <a:t>• 첫 번째 충격으로 발생한 진동을, 두 번째 충격(임펄스)으로 정확히 상쇄(Cancel out)</a:t>
-            </a:r>
-          </a:p>
-          <a:p>
-            <a:r>
-              <a:t>• 로봇 팔의 고유진동수(fn)와 감쇠비(zeta)를 계산하여 맞춤형 쉐이퍼 설계</a:t>
-            </a:r>
-          </a:p>
-        </p:txBody>
-      </p:sp>
-    </p:spTree>
-  </p:cSld>
-  <p:clrMapOvr>
-    <a:masterClrMapping/>
-  </p:clrMapOvr>
-</p:sld>
-</file>
-
-<file path=ppt/slides/slide14.xml><?xml version="1.0" encoding="utf-8"?>
-<p:sld xmlns:a="http://schemas.openxmlformats.org/drawingml/2006/main" xmlns:p="http://schemas.openxmlformats.org/presentationml/2006/main" xmlns:r="http://schemas.openxmlformats.org/officeDocument/2006/relationships">
-  <p:cSld>
-    <p:spTree>
-      <p:nvGrpSpPr>
-        <p:cNvPr id="1" name=""/>
-        <p:cNvGrpSpPr/>
-        <p:nvPr/>
-      </p:nvGrpSpPr>
-      <p:grpSpPr/>
-      <p:sp>
-        <p:nvSpPr>
-          <p:cNvPr id="2" name="Content Placeholder 1"/>
-          <p:cNvSpPr>
-            <a:spLocks noGrp="1"/>
-          </p:cNvSpPr>
-          <p:nvPr>
-            <p:ph idx="1"/>
-          </p:nvPr>
-        </p:nvSpPr>
-        <p:spPr/>
-        <p:txBody>
-          <a:bodyPr/>
-          <a:lstStyle/>
-          <a:p/>
-        </p:txBody>
-      </p:sp>
-      <p:sp>
-        <p:nvSpPr>
-          <p:cNvPr id="3" name="TextBox 2"/>
-          <p:cNvSpPr txBox="1"/>
-          <p:nvPr/>
-        </p:nvSpPr>
-        <p:spPr>
-          <a:xfrm>
-            <a:off x="635000" y="1270000"/>
-            <a:ext cx="10922000" cy="4953000"/>
-          </a:xfrm>
-          <a:prstGeom prst="rect">
-            <a:avLst/>
-          </a:prstGeom>
-          <a:noFill/>
-        </p:spPr>
-        <p:txBody>
-          <a:bodyPr wrap="square">
-            <a:spAutoFit/>
-          </a:bodyPr>
-          <a:lstStyle/>
-          <a:p>
-            <a:r>
-              <a:t>4. 디지털 트윈 및 AI 자동 튜닝 개발</a:t>
-            </a:r>
-          </a:p>
-          <a:p/>
-          <a:p>
-            <a:r>
-              <a:t>• 이론적 계산을 넘어 실제 3D 시뮬레이션 환경(Digital Twin) 구현</a:t>
-            </a:r>
-          </a:p>
-          <a:p>
-            <a:r>
-              <a:t>• 4가지 고해상도 실시간 분석 차트 탑재</a:t>
-            </a:r>
-          </a:p>
-          <a:p>
-            <a:r>
-              <a:t>• AI 최적화 (Particle Swarm Optimization):</a:t>
-            </a:r>
-          </a:p>
-          <a:p>
-            <a:r>
-              <a:t>  - 사람이 찾기 힘든 최적의 변수를 백그라운드에서 자동 탐색</a:t>
-            </a:r>
-          </a:p>
-        </p:txBody>
-      </p:sp>
-    </p:spTree>
-  </p:cSld>
-  <p:clrMapOvr>
-    <a:masterClrMapping/>
-  </p:clrMapOvr>
-</p:sld>
-</file>
-
-<file path=ppt/slides/slide15.xml><?xml version="1.0" encoding="utf-8"?>
-<p:sld xmlns:a="http://schemas.openxmlformats.org/drawingml/2006/main" xmlns:p="http://schemas.openxmlformats.org/presentationml/2006/main" xmlns:r="http://schemas.openxmlformats.org/officeDocument/2006/relationships">
-  <p:cSld>
-    <p:spTree>
-      <p:nvGrpSpPr>
-        <p:cNvPr id="1" name=""/>
-        <p:cNvGrpSpPr/>
-        <p:nvPr/>
-      </p:nvGrpSpPr>
-      <p:grpSpPr/>
-      <p:sp>
-        <p:nvSpPr>
-          <p:cNvPr id="2" name="Content Placeholder 1"/>
-          <p:cNvSpPr>
-            <a:spLocks noGrp="1"/>
-          </p:cNvSpPr>
-          <p:nvPr>
-            <p:ph idx="1"/>
-          </p:nvPr>
-        </p:nvSpPr>
-        <p:spPr/>
-        <p:txBody>
-          <a:bodyPr/>
-          <a:lstStyle/>
-          <a:p/>
-        </p:txBody>
-      </p:sp>
-      <p:sp>
-        <p:nvSpPr>
-          <p:cNvPr id="3" name="TextBox 2"/>
-          <p:cNvSpPr txBox="1"/>
-          <p:nvPr/>
-        </p:nvSpPr>
-        <p:spPr>
-          <a:xfrm>
-            <a:off x="635000" y="1270000"/>
-            <a:ext cx="10922000" cy="4953000"/>
-          </a:xfrm>
-          <a:prstGeom prst="rect">
-            <a:avLst/>
-          </a:prstGeom>
-          <a:noFill/>
-        </p:spPr>
-        <p:txBody>
-          <a:bodyPr wrap="square">
-            <a:spAutoFit/>
-          </a:bodyPr>
-          <a:lstStyle/>
-          <a:p>
-            <a:r>
-              <a:t>5. 결과 분석 및 기대효과</a:t>
-            </a:r>
-          </a:p>
-          <a:p/>
-          <a:p>
-            <a:r>
-              <a:t>• [결과] 제어 미적용 시 대비 정착 시간 대폭 감소 및 진동 제거 확인</a:t>
-            </a:r>
-          </a:p>
-          <a:p>
-            <a:r>
-              <a:t>• [효과] 오프라인 환경에서 모터 파라미터 사전 튜닝 가능</a:t>
-            </a:r>
-          </a:p>
-          <a:p>
-            <a:r>
-              <a:t>• [결론] 장비 셋업 시간 단축 및 실질적 UPH 향상에 기여</a:t>
-            </a:r>
-          </a:p>
-        </p:txBody>
-      </p:sp>
-    </p:spTree>
+    <p:extLst>
+      <p:ext uri="{BB962C8B-B14F-4D97-AF65-F5344CB8AC3E}">
+        <p14:creationId xmlns:p14="http://schemas.microsoft.com/office/powerpoint/2010/main" val="4288557334"/>
+      </p:ext>
+    </p:extLst>
   </p:cSld>
   <p:clrMapOvr>
     <a:masterClrMapping/>
@@ -7732,162 +7377,43 @@
           </a:bodyPr>
           <a:lstStyle/>
           <a:p>
-            <a:pPr marL="514350" indent="-514350">
-              <a:lnSpc>
-                <a:spcPct val="170000"/>
-              </a:lnSpc>
-              <a:buFont typeface="+mj-lt"/>
-              <a:buAutoNum type="arabicPeriod"/>
-            </a:pPr>
-            <a:r>
-              <a:rPr lang="ko-KR" altLang="en-US" dirty="0">
-                <a:ln w="19050">
-                  <a:solidFill>
-                    <a:schemeClr val="tx1"/>
-                  </a:solidFill>
-                </a:ln>
-              </a:rPr>
-              <a:t>프로젝트 제작동기</a:t>
-            </a:r>
-            <a:endParaRPr lang="en-US" altLang="ko-KR" dirty="0">
-              <a:ln w="19050">
-                <a:solidFill>
-                  <a:schemeClr val="tx1"/>
-                </a:solidFill>
-              </a:ln>
-            </a:endParaRPr>
-          </a:p>
-          <a:p>
-            <a:pPr marL="514350" indent="-514350">
-              <a:lnSpc>
-                <a:spcPct val="170000"/>
-              </a:lnSpc>
-              <a:buFont typeface="+mj-lt"/>
-              <a:buAutoNum type="arabicPeriod"/>
-            </a:pPr>
-            <a:r>
-              <a:rPr lang="ko-KR" altLang="en-US" dirty="0">
-                <a:ln w="19050">
-                  <a:solidFill>
-                    <a:schemeClr val="tx1"/>
-                  </a:solidFill>
-                </a:ln>
-              </a:rPr>
-              <a:t>프로젝트 제작과정</a:t>
-            </a:r>
-            <a:endParaRPr lang="en-US" altLang="ko-KR" dirty="0">
-              <a:ln w="19050">
-                <a:solidFill>
-                  <a:schemeClr val="tx1"/>
-                </a:solidFill>
-              </a:ln>
-            </a:endParaRPr>
-          </a:p>
-          <a:p>
-            <a:pPr marL="514350" indent="-514350">
-              <a:lnSpc>
-                <a:spcPct val="170000"/>
-              </a:lnSpc>
-              <a:buFont typeface="+mj-lt"/>
-              <a:buAutoNum type="arabicPeriod"/>
-            </a:pPr>
-            <a:r>
-              <a:rPr lang="ko-KR" altLang="en-US" dirty="0">
-                <a:ln w="19050">
-                  <a:solidFill>
-                    <a:schemeClr val="tx1"/>
-                  </a:solidFill>
-                </a:ln>
-              </a:rPr>
-              <a:t>작품설명</a:t>
-            </a:r>
-            <a:endParaRPr lang="en-US" altLang="ko-KR" dirty="0">
-              <a:ln w="19050">
-                <a:solidFill>
-                  <a:schemeClr val="tx1"/>
-                </a:solidFill>
-              </a:ln>
-            </a:endParaRPr>
-          </a:p>
-          <a:p>
-            <a:pPr marL="514350" indent="-514350">
-              <a:lnSpc>
-                <a:spcPct val="170000"/>
-              </a:lnSpc>
-              <a:buFont typeface="+mj-lt"/>
-              <a:buAutoNum type="arabicPeriod"/>
-            </a:pPr>
-            <a:r>
-              <a:rPr lang="ko-KR" altLang="en-US" dirty="0">
-                <a:ln w="19050">
-                  <a:solidFill>
-                    <a:schemeClr val="tx1"/>
-                  </a:solidFill>
-                </a:ln>
-              </a:rPr>
-              <a:t>프로젝트 결과</a:t>
-            </a:r>
-            <a:endParaRPr lang="en-US" altLang="ko-KR" dirty="0">
-              <a:ln w="19050">
-                <a:solidFill>
-                  <a:schemeClr val="tx1"/>
-                </a:solidFill>
-              </a:ln>
-            </a:endParaRPr>
-          </a:p>
-          <a:p>
-            <a:pPr marL="514350" indent="-514350">
-              <a:lnSpc>
-                <a:spcPct val="170000"/>
-              </a:lnSpc>
-              <a:buFont typeface="+mj-lt"/>
-              <a:buAutoNum type="arabicPeriod"/>
-            </a:pPr>
-            <a:r>
-              <a:rPr lang="ko-KR" altLang="en-US" dirty="0">
-                <a:ln w="19050">
-                  <a:solidFill>
-                    <a:schemeClr val="tx1"/>
-                  </a:solidFill>
-                </a:ln>
-              </a:rPr>
-              <a:t>결과분석 및 토의</a:t>
-            </a:r>
-            <a:endParaRPr lang="en-US" altLang="ko-KR" dirty="0">
-              <a:ln w="19050">
-                <a:solidFill>
-                  <a:schemeClr val="tx1"/>
-                </a:solidFill>
-              </a:ln>
-            </a:endParaRPr>
-          </a:p>
-          <a:p>
-            <a:pPr marL="514350" indent="-514350">
-              <a:lnSpc>
-                <a:spcPct val="170000"/>
-              </a:lnSpc>
-              <a:buFont typeface="+mj-lt"/>
-              <a:buAutoNum type="arabicPeriod"/>
-            </a:pPr>
-            <a:r>
-              <a:rPr lang="ko-KR" altLang="en-US" dirty="0" err="1">
-                <a:ln w="19050">
-                  <a:solidFill>
-                    <a:schemeClr val="tx1"/>
-                  </a:solidFill>
-                </a:ln>
-              </a:rPr>
-              <a:t>느낀점</a:t>
-            </a:r>
-            <a:r>
-              <a:rPr lang="ko-KR" altLang="en-US" dirty="0">
-                <a:ln w="19050">
-                  <a:solidFill>
-                    <a:schemeClr val="tx1"/>
-                  </a:solidFill>
-                </a:ln>
-              </a:rPr>
-              <a:t> 및 애로사항</a:t>
+            <a:r>
+              <a:t>1. 연구 배경 및 목적</a:t>
+            </a:r>
+          </a:p>
+          <a:p>
+            <a:r>
+              <a:t>2. 시스템 모델링</a:t>
+            </a:r>
+          </a:p>
+          <a:p>
+            <a:r>
+              <a:t>3. 모션 프로파일 비교 (AS-Curve &amp; Input Shaping)</a:t>
+            </a:r>
+          </a:p>
+          <a:p>
+            <a:r>
+              <a:t>4. 인풋쉐이핑 원리 (ZVD)</a:t>
+            </a:r>
+          </a:p>
+          <a:p>
+            <a:r>
+              <a:t>5. 디지털 트윈 시뮬레이터 구현</a:t>
+            </a:r>
+          </a:p>
+          <a:p>
+            <a:r>
+              <a:t>6. 실험 결과 — 동일 조건 비교</a:t>
+            </a:r>
+          </a:p>
+          <a:p>
+            <a:r>
+              <a:t>7. 핵심 결론</a:t>
+            </a:r>
+          </a:p>
+          <a:p>
+            <a:r>
+              <a:t>8. 한계점 및 향후 과제</a:t>
             </a:r>
           </a:p>
         </p:txBody>
@@ -7948,20 +7474,44 @@
           <a:bodyPr/>
           <a:lstStyle/>
           <a:p>
-            <a:pPr marL="0" indent="0" algn="ctr">
-              <a:buNone/>
-            </a:pPr>
-            <a:r>
-              <a:rPr lang="ko-KR" altLang="en-US" dirty="0"/>
-              <a:t>작품배경 및 동기</a:t>
-            </a:r>
-            <a:endParaRPr lang="en-US" altLang="ko-KR" dirty="0"/>
-          </a:p>
-          <a:p>
-            <a:pPr marL="0" indent="0" algn="ctr">
-              <a:buNone/>
-            </a:pPr>
-            <a:endParaRPr lang="ko-KR" altLang="en-US" dirty="0"/>
+            <a:r>
+              <a:t>• 반도체 패키징 공정의 Pick &amp; Place 로봇은</a:t>
+            </a:r>
+          </a:p>
+          <a:p>
+            <a:r>
+              <a:t>  갠트리(X축)의 고속 이동 시 잔류 진동 발생</a:t>
+            </a:r>
+          </a:p>
+          <a:p>
+            <a:r>
+              <a:t/>
+            </a:r>
+          </a:p>
+          <a:p>
+            <a:r>
+              <a:t>• 잔류 진동 → 정착 시간 증가 → UPH 저하</a:t>
+            </a:r>
+          </a:p>
+          <a:p>
+            <a:r>
+              <a:t/>
+            </a:r>
+          </a:p>
+          <a:p>
+            <a:r>
+              <a:t>• 목적:</a:t>
+            </a:r>
+          </a:p>
+          <a:p>
+            <a:r>
+              <a:t>  AS-Curve 궤적 + ZVD 인풋쉐이핑으로</a:t>
+            </a:r>
+          </a:p>
+          <a:p>
+            <a:r>
+              <a:t>  잔류 진동을 근본 억제하여 UPH 극대화</a:t>
+            </a:r>
           </a:p>
         </p:txBody>
       </p:sp>
@@ -7992,12 +7542,7 @@
           <a:lstStyle/>
           <a:p>
             <a:r>
-              <a:rPr lang="en-US" altLang="ko-KR" dirty="0"/>
-              <a:t>01  </a:t>
-            </a:r>
-            <a:r>
-              <a:rPr lang="ko-KR" altLang="en-US" dirty="0"/>
-              <a:t>프로젝트 제작동기</a:t>
+              <a:t>1. 연구 배경 및 목적</a:t>
             </a:r>
           </a:p>
         </p:txBody>
@@ -9403,12 +8948,7 @@
           <a:lstStyle/>
           <a:p>
             <a:r>
-              <a:rPr lang="en-US" altLang="ko-KR" dirty="0"/>
-              <a:t>02  </a:t>
-            </a:r>
-            <a:r>
-              <a:rPr lang="ko-KR" altLang="en-US" dirty="0"/>
-              <a:t>프로젝트 제작과정</a:t>
+              <a:t>2. 시스템 모델링: 2-Mass Perfect Servo</a:t>
             </a:r>
           </a:p>
         </p:txBody>
@@ -9605,14 +9145,69 @@
             </a:lvl9pPr>
           </a:lstStyle>
           <a:p>
-            <a:pPr marL="0" indent="0">
-              <a:buFont typeface="Arial" panose="020B0604020202020204" pitchFamily="34" charset="0"/>
-              <a:buNone/>
-            </a:pPr>
-            <a:endParaRPr lang="ko-KR" altLang="en-US" sz="2000" dirty="0">
-              <a:latin typeface="맑은 고딕" panose="020B0503020000020004" pitchFamily="50" charset="-127"/>
-              <a:ea typeface="맑은 고딕" panose="020B0503020000020004" pitchFamily="50" charset="-127"/>
-            </a:endParaRPr>
+            <a:r>
+              <a:t>• 2-Mass Perfect Servo 모델</a:t>
+            </a:r>
+          </a:p>
+          <a:p>
+            <a:r>
+              <a:t>  - 모터(캐리지): 명령 궤적을 완벽히 추종</a:t>
+            </a:r>
+          </a:p>
+          <a:p>
+            <a:r>
+              <a:t>  - 로드(엔드이펙터): 스프링-댐퍼로 캐리지에 연결</a:t>
+            </a:r>
+          </a:p>
+          <a:p>
+            <a:r>
+              <a:t/>
+            </a:r>
+          </a:p>
+          <a:p>
+            <a:r>
+              <a:t>• 물리 방정식</a:t>
+            </a:r>
+          </a:p>
+          <a:p>
+            <a:r>
+              <a:t>  F = k·(x₁ - x₂) + c·(v₁ - v₂)</a:t>
+            </a:r>
+          </a:p>
+          <a:p>
+            <a:r>
+              <a:t>  a₂ = F / m₂</a:t>
+            </a:r>
+          </a:p>
+          <a:p>
+            <a:r>
+              <a:t/>
+            </a:r>
+          </a:p>
+          <a:p>
+            <a:r>
+              <a:t>• 수치 적분: RK4 (10× substep, dt = 0.1 ms)</a:t>
+            </a:r>
+          </a:p>
+          <a:p>
+            <a:r>
+              <a:t/>
+            </a:r>
+          </a:p>
+          <a:p>
+            <a:r>
+              <a:t>• 설계 파라미터</a:t>
+            </a:r>
+          </a:p>
+          <a:p>
+            <a:r>
+              <a:t>  - 고유진동수 fn = 10 Hz</a:t>
+            </a:r>
+          </a:p>
+          <a:p>
+            <a:r>
+              <a:t>  - 감쇠비 ζ = 0.05</a:t>
+            </a:r>
           </a:p>
         </p:txBody>
       </p:sp>
@@ -9680,7 +9275,59 @@
           </a:bodyPr>
           <a:lstStyle/>
           <a:p>
-            <a:endParaRPr lang="en-US" altLang="ko-KR" sz="2300" dirty="0"/>
+            <a:r>
+              <a:t>① Trapezoidal</a:t>
+            </a:r>
+          </a:p>
+          <a:p>
+            <a:r>
+              <a:t>  • 가속도가 순간 변화 → 저크 무제한</a:t>
+            </a:r>
+          </a:p>
+          <a:p>
+            <a:r>
+              <a:t>  • 최대 진동 유발 (비교 기준)</a:t>
+            </a:r>
+          </a:p>
+          <a:p>
+            <a:r>
+              <a:t/>
+            </a:r>
+          </a:p>
+          <a:p>
+            <a:r>
+              <a:t>② AS-Curve (비대칭 S-Curve)</a:t>
+            </a:r>
+          </a:p>
+          <a:p>
+            <a:r>
+              <a:t>  • 7-segment 비대칭 저크 제한</a:t>
+            </a:r>
+          </a:p>
+          <a:p>
+            <a:r>
+              <a:t>  • 기구부 충격 완화</a:t>
+            </a:r>
+          </a:p>
+          <a:p>
+            <a:r>
+              <a:t/>
+            </a:r>
+          </a:p>
+          <a:p>
+            <a:r>
+              <a:t>③ AS-Curve + ZVD</a:t>
+            </a:r>
+          </a:p>
+          <a:p>
+            <a:r>
+              <a:t>  • 인풋쉐이핑으로 잔류 진동 근본 상쇄</a:t>
+            </a:r>
+          </a:p>
+          <a:p>
+            <a:r>
+              <a:t>  • 정착 시간 획기적 단축</a:t>
+            </a:r>
           </a:p>
         </p:txBody>
       </p:sp>
@@ -9713,12 +9360,7 @@
           <a:lstStyle/>
           <a:p>
             <a:r>
-              <a:rPr lang="en-US" altLang="ko-KR" dirty="0"/>
-              <a:t>02  </a:t>
-            </a:r>
-            <a:r>
-              <a:rPr lang="ko-KR" altLang="en-US" dirty="0"/>
-              <a:t>프로젝트 제작과정</a:t>
+              <a:t>3. 모션 프로파일 비교</a:t>
             </a:r>
           </a:p>
         </p:txBody>
@@ -9780,12 +9422,7 @@
           <a:lstStyle/>
           <a:p>
             <a:r>
-              <a:rPr lang="en-US" altLang="ko-KR" dirty="0"/>
-              <a:t>03  </a:t>
-            </a:r>
-            <a:r>
-              <a:rPr lang="ko-KR" altLang="en-US" dirty="0"/>
-              <a:t>작품설명</a:t>
+              <a:t>4. 인풋쉐이핑 원리: ZVD 쉐이퍼</a:t>
             </a:r>
           </a:p>
         </p:txBody>
@@ -9982,14 +9619,54 @@
             </a:lvl9pPr>
           </a:lstStyle>
           <a:p>
-            <a:pPr marL="0" indent="0">
-              <a:buFont typeface="Arial" panose="020B0604020202020204" pitchFamily="34" charset="0"/>
-              <a:buNone/>
-            </a:pPr>
-            <a:endParaRPr lang="ko-KR" altLang="en-US" sz="2000" dirty="0">
-              <a:latin typeface="맑은 고딕" panose="020B0503020000020004" pitchFamily="50" charset="-127"/>
-              <a:ea typeface="맑은 고딕" panose="020B0503020000020004" pitchFamily="50" charset="-127"/>
-            </a:endParaRPr>
+            <a:r>
+              <a:t>• ZVD(Zero Vibration and Derivative) 쉐이퍼</a:t>
+            </a:r>
+          </a:p>
+          <a:p>
+            <a:r>
+              <a:t>  - 3개 임펄스를 고유진동 반주기 간격으로 배치</a:t>
+            </a:r>
+          </a:p>
+          <a:p>
+            <a:r>
+              <a:t/>
+            </a:r>
+          </a:p>
+          <a:p>
+            <a:r>
+              <a:t>• 동작 원리</a:t>
+            </a:r>
+          </a:p>
+          <a:p>
+            <a:r>
+              <a:t>  - 파괴적 간섭(Destructive Interference)으로</a:t>
+            </a:r>
+          </a:p>
+          <a:p>
+            <a:r>
+              <a:t>    잔류 진동을 이론적으로 0으로 억제</a:t>
+            </a:r>
+          </a:p>
+          <a:p>
+            <a:r>
+              <a:t/>
+            </a:r>
+          </a:p>
+          <a:p>
+            <a:r>
+              <a:t>• 쉐이퍼 지연: ~100 ms</a:t>
+            </a:r>
+          </a:p>
+          <a:p>
+            <a:r>
+              <a:t>  - 고속 이동 시간(~95 ms) 대비 매우 짧음</a:t>
+            </a:r>
+          </a:p>
+          <a:p>
+            <a:r>
+              <a:t>  - 이 지연 투자로 2.5초의 진동 대기 제거</a:t>
+            </a:r>
           </a:p>
         </p:txBody>
       </p:sp>
@@ -10058,12 +9735,90 @@
           <a:lstStyle/>
           <a:p>
             <a:r>
-              <a:rPr lang="en-US" altLang="ko-KR" dirty="0"/>
-              <a:t>04  </a:t>
-            </a:r>
-            <a:r>
-              <a:rPr lang="ko-KR" altLang="en-US" dirty="0"/>
-              <a:t>프로젝트 결과</a:t>
+              <a:t>5. 디지털 트윈 시뮬레이터 구현</a:t>
+            </a:r>
+          </a:p>
+        </p:txBody>
+      </p:sp>
+      <p:sp>
+        <p:nvSpPr>
+          <p:cNvPr id="6" name="TextBox 5"/>
+          <p:cNvSpPr txBox="1"/>
+          <p:nvPr/>
+        </p:nvSpPr>
+        <p:spPr>
+          <a:xfrm>
+            <a:off x="792000" y="2015999"/>
+            <a:ext cx="8640000" cy="2880000"/>
+          </a:xfrm>
+          <a:prstGeom prst="rect">
+            <a:avLst/>
+          </a:prstGeom>
+          <a:noFill/>
+        </p:spPr>
+        <p:txBody>
+          <a:bodyPr wrap="square">
+            <a:spAutoFit/>
+          </a:bodyPr>
+          <a:lstStyle/>
+          <a:p>
+            <a:r>
+              <a:rPr sz="1400" b="0"/>
+              <a:t>• Three.js 기반 3D 실시간 시각화</a:t>
+            </a:r>
+          </a:p>
+          <a:p>
+            <a:r>
+              <a:rPr sz="1400" b="0"/>
+              <a:t>  - Shaped(제어 적용) vs Unshaped(고스트) 로봇 동시 비교</a:t>
+            </a:r>
+          </a:p>
+          <a:p>
+            <a:r>
+              <a:rPr sz="1400" b="0"/>
+              <a:t/>
+            </a:r>
+          </a:p>
+          <a:p>
+            <a:r>
+              <a:rPr sz="1400" b="0"/>
+              <a:t>• Chart.js 기반 실시간 분석 차트</a:t>
+            </a:r>
+          </a:p>
+          <a:p>
+            <a:r>
+              <a:rPr sz="1400" b="0"/>
+              <a:t>  - 위치 / 속도 / 가속도 / 잔류진동 4채널</a:t>
+            </a:r>
+          </a:p>
+          <a:p>
+            <a:r>
+              <a:rPr sz="1400" b="0"/>
+              <a:t/>
+            </a:r>
+          </a:p>
+          <a:p>
+            <a:r>
+              <a:rPr sz="1400" b="0"/>
+              <a:t>• AI PSO(Particle Swarm Optimization) 자동 튜닝 탑재</a:t>
+            </a:r>
+          </a:p>
+          <a:p>
+            <a:r>
+              <a:rPr sz="1400" b="0"/>
+              <a:t>  - V_max, A_max, Beta, Gamma 최적 파라미터 자동 탐색</a:t>
+            </a:r>
+          </a:p>
+          <a:p>
+            <a:r>
+              <a:rPr sz="1400" b="0"/>
+              <a:t/>
+            </a:r>
+          </a:p>
+          <a:p>
+            <a:r>
+              <a:rPr sz="1400" b="0"/>
+              <a:t>• 웹 브라우저에서 즉시 구동 가능한 경량 시뮬레이터</a:t>
             </a:r>
           </a:p>
         </p:txBody>
@@ -10125,12 +9880,406 @@
           <a:lstStyle/>
           <a:p>
             <a:r>
-              <a:rPr lang="en-US" altLang="ko-KR" dirty="0"/>
-              <a:t>05  </a:t>
-            </a:r>
-            <a:r>
-              <a:rPr lang="ko-KR" altLang="en-US" dirty="0"/>
-              <a:t>결과분석 및 토의</a:t>
+              <a:t>6. 실험 결과 — 동일 조건 비교 ★</a:t>
+            </a:r>
+          </a:p>
+        </p:txBody>
+      </p:sp>
+      <p:graphicFrame>
+        <p:nvGraphicFramePr>
+          <p:cNvPr id="12" name="Table 11"/>
+          <p:cNvGraphicFramePr>
+            <a:graphicFrameLocks noGrp="1"/>
+          </p:cNvGraphicFramePr>
+          <p:nvPr/>
+        </p:nvGraphicFramePr>
+        <p:xfrm>
+          <a:off x="900000" y="1728000"/>
+          <a:ext cx="6120000" cy="2160000"/>
+        </p:xfrm>
+        <a:graphic>
+          <a:graphicData uri="http://schemas.openxmlformats.org/drawingml/2006/table">
+            <a:tbl>
+              <a:tblPr firstRow="1" bandRow="1">
+                <a:tableStyleId>{5C22544A-7EE6-4342-B048-85BDC9FD1C3A}</a:tableStyleId>
+              </a:tblPr>
+              <a:tblGrid>
+                <a:gridCol w="1260000"/>
+                <a:gridCol w="1620000"/>
+                <a:gridCol w="1620000"/>
+                <a:gridCol w="1620000"/>
+              </a:tblGrid>
+              <a:tr h="432000">
+                <a:tc>
+                  <a:txBody>
+                    <a:bodyPr/>
+                    <a:lstStyle/>
+                    <a:p>
+                      <a:pPr algn="ctr"/>
+                      <a:r>
+                        <a:rPr sz="1100" b="1">
+                          <a:solidFill>
+                            <a:srgbClr val="FFFFFF"/>
+                          </a:solidFill>
+                        </a:rPr>
+                        <a:t>지표</a:t>
+                      </a:r>
+                    </a:p>
+                  </a:txBody>
+                  <a:tcPr anchor="ctr">
+                    <a:solidFill>
+                      <a:srgbClr val="1F497D"/>
+                    </a:solidFill>
+                  </a:tcPr>
+                </a:tc>
+                <a:tc>
+                  <a:txBody>
+                    <a:bodyPr/>
+                    <a:lstStyle/>
+                    <a:p>
+                      <a:pPr algn="ctr"/>
+                      <a:r>
+                        <a:rPr sz="1100" b="1">
+                          <a:solidFill>
+                            <a:srgbClr val="FFFFFF"/>
+                          </a:solidFill>
+                        </a:rPr>
+                        <a:t>Trapezoidal</a:t>
+                      </a:r>
+                    </a:p>
+                  </a:txBody>
+                  <a:tcPr anchor="ctr">
+                    <a:solidFill>
+                      <a:srgbClr val="1F497D"/>
+                    </a:solidFill>
+                  </a:tcPr>
+                </a:tc>
+                <a:tc>
+                  <a:txBody>
+                    <a:bodyPr/>
+                    <a:lstStyle/>
+                    <a:p>
+                      <a:pPr algn="ctr"/>
+                      <a:r>
+                        <a:rPr sz="1100" b="1">
+                          <a:solidFill>
+                            <a:srgbClr val="FFFFFF"/>
+                          </a:solidFill>
+                        </a:rPr>
+                        <a:t>AS-Curve</a:t>
+                      </a:r>
+                    </a:p>
+                  </a:txBody>
+                  <a:tcPr anchor="ctr">
+                    <a:solidFill>
+                      <a:srgbClr val="1F497D"/>
+                    </a:solidFill>
+                  </a:tcPr>
+                </a:tc>
+                <a:tc>
+                  <a:txBody>
+                    <a:bodyPr/>
+                    <a:lstStyle/>
+                    <a:p>
+                      <a:pPr algn="ctr"/>
+                      <a:r>
+                        <a:rPr sz="1100" b="1">
+                          <a:solidFill>
+                            <a:srgbClr val="FFFFFF"/>
+                          </a:solidFill>
+                        </a:rPr>
+                        <a:t>AS-Curve + ZVD</a:t>
+                      </a:r>
+                    </a:p>
+                  </a:txBody>
+                  <a:tcPr anchor="ctr">
+                    <a:solidFill>
+                      <a:srgbClr val="1F497D"/>
+                    </a:solidFill>
+                  </a:tcPr>
+                </a:tc>
+              </a:tr>
+              <a:tr h="432000">
+                <a:tc>
+                  <a:txBody>
+                    <a:bodyPr/>
+                    <a:lstStyle/>
+                    <a:p>
+                      <a:pPr algn="ctr"/>
+                      <a:r>
+                        <a:rPr sz="1100" b="0"/>
+                        <a:t>이동 시간</a:t>
+                      </a:r>
+                    </a:p>
+                  </a:txBody>
+                  <a:tcPr anchor="ctr"/>
+                </a:tc>
+                <a:tc>
+                  <a:txBody>
+                    <a:bodyPr/>
+                    <a:lstStyle/>
+                    <a:p>
+                      <a:pPr algn="ctr"/>
+                      <a:r>
+                        <a:rPr sz="1100" b="0"/>
+                        <a:t>0.1000 s</a:t>
+                      </a:r>
+                    </a:p>
+                  </a:txBody>
+                  <a:tcPr anchor="ctr"/>
+                </a:tc>
+                <a:tc>
+                  <a:txBody>
+                    <a:bodyPr/>
+                    <a:lstStyle/>
+                    <a:p>
+                      <a:pPr algn="ctr"/>
+                      <a:r>
+                        <a:rPr sz="1100" b="0"/>
+                        <a:t>0.0950 s</a:t>
+                      </a:r>
+                    </a:p>
+                  </a:txBody>
+                  <a:tcPr anchor="ctr"/>
+                </a:tc>
+                <a:tc>
+                  <a:txBody>
+                    <a:bodyPr/>
+                    <a:lstStyle/>
+                    <a:p>
+                      <a:pPr algn="ctr"/>
+                      <a:r>
+                        <a:rPr sz="1100" b="0"/>
+                        <a:t>0.0950 s</a:t>
+                      </a:r>
+                    </a:p>
+                  </a:txBody>
+                  <a:tcPr anchor="ctr">
+                    <a:solidFill>
+                      <a:srgbClr val="DBE5F1"/>
+                    </a:solidFill>
+                  </a:tcPr>
+                </a:tc>
+              </a:tr>
+              <a:tr h="432000">
+                <a:tc>
+                  <a:txBody>
+                    <a:bodyPr/>
+                    <a:lstStyle/>
+                    <a:p>
+                      <a:pPr algn="ctr"/>
+                      <a:r>
+                        <a:rPr sz="1100" b="0"/>
+                        <a:t>잔류 진동</a:t>
+                      </a:r>
+                    </a:p>
+                  </a:txBody>
+                  <a:tcPr anchor="ctr"/>
+                </a:tc>
+                <a:tc>
+                  <a:txBody>
+                    <a:bodyPr/>
+                    <a:lstStyle/>
+                    <a:p>
+                      <a:pPr algn="ctr"/>
+                      <a:r>
+                        <a:rPr sz="1100" b="0"/>
+                        <a:t>17.47 mm</a:t>
+                      </a:r>
+                    </a:p>
+                  </a:txBody>
+                  <a:tcPr anchor="ctr"/>
+                </a:tc>
+                <a:tc>
+                  <a:txBody>
+                    <a:bodyPr/>
+                    <a:lstStyle/>
+                    <a:p>
+                      <a:pPr algn="ctr"/>
+                      <a:r>
+                        <a:rPr sz="1100" b="0"/>
+                        <a:t>24.66 mm</a:t>
+                      </a:r>
+                    </a:p>
+                  </a:txBody>
+                  <a:tcPr anchor="ctr"/>
+                </a:tc>
+                <a:tc>
+                  <a:txBody>
+                    <a:bodyPr/>
+                    <a:lstStyle/>
+                    <a:p>
+                      <a:pPr algn="ctr"/>
+                      <a:r>
+                        <a:rPr sz="1100" b="0"/>
+                        <a:t>4.29 mm</a:t>
+                      </a:r>
+                    </a:p>
+                  </a:txBody>
+                  <a:tcPr anchor="ctr">
+                    <a:solidFill>
+                      <a:srgbClr val="DBE5F1"/>
+                    </a:solidFill>
+                  </a:tcPr>
+                </a:tc>
+              </a:tr>
+              <a:tr h="432000">
+                <a:tc>
+                  <a:txBody>
+                    <a:bodyPr/>
+                    <a:lstStyle/>
+                    <a:p>
+                      <a:pPr algn="ctr"/>
+                      <a:r>
+                        <a:rPr sz="1100" b="0"/>
+                        <a:t>정착 시간</a:t>
+                      </a:r>
+                    </a:p>
+                  </a:txBody>
+                  <a:tcPr anchor="ctr"/>
+                </a:tc>
+                <a:tc>
+                  <a:txBody>
+                    <a:bodyPr/>
+                    <a:lstStyle/>
+                    <a:p>
+                      <a:pPr algn="ctr"/>
+                      <a:r>
+                        <a:rPr sz="1100" b="0"/>
+                        <a:t>2.660 s</a:t>
+                      </a:r>
+                    </a:p>
+                  </a:txBody>
+                  <a:tcPr anchor="ctr"/>
+                </a:tc>
+                <a:tc>
+                  <a:txBody>
+                    <a:bodyPr/>
+                    <a:lstStyle/>
+                    <a:p>
+                      <a:pPr algn="ctr"/>
+                      <a:r>
+                        <a:rPr sz="1100" b="0"/>
+                        <a:t>2.815 s</a:t>
+                      </a:r>
+                    </a:p>
+                  </a:txBody>
+                  <a:tcPr anchor="ctr"/>
+                </a:tc>
+                <a:tc>
+                  <a:txBody>
+                    <a:bodyPr/>
+                    <a:lstStyle/>
+                    <a:p>
+                      <a:pPr algn="ctr"/>
+                      <a:r>
+                        <a:rPr sz="1100" b="0"/>
+                        <a:t>0.197 s</a:t>
+                      </a:r>
+                    </a:p>
+                  </a:txBody>
+                  <a:tcPr anchor="ctr">
+                    <a:solidFill>
+                      <a:srgbClr val="DBE5F1"/>
+                    </a:solidFill>
+                  </a:tcPr>
+                </a:tc>
+              </a:tr>
+              <a:tr h="432000">
+                <a:tc>
+                  <a:txBody>
+                    <a:bodyPr/>
+                    <a:lstStyle/>
+                    <a:p>
+                      <a:pPr algn="ctr"/>
+                      <a:r>
+                        <a:rPr sz="1100" b="0"/>
+                        <a:t>UPH</a:t>
+                      </a:r>
+                    </a:p>
+                  </a:txBody>
+                  <a:tcPr anchor="ctr"/>
+                </a:tc>
+                <a:tc>
+                  <a:txBody>
+                    <a:bodyPr/>
+                    <a:lstStyle/>
+                    <a:p>
+                      <a:pPr algn="ctr"/>
+                      <a:r>
+                        <a:rPr sz="1100" b="0"/>
+                        <a:t>676</a:t>
+                      </a:r>
+                    </a:p>
+                  </a:txBody>
+                  <a:tcPr anchor="ctr"/>
+                </a:tc>
+                <a:tc>
+                  <a:txBody>
+                    <a:bodyPr/>
+                    <a:lstStyle/>
+                    <a:p>
+                      <a:pPr algn="ctr"/>
+                      <a:r>
+                        <a:rPr sz="1100" b="0"/>
+                        <a:t>639</a:t>
+                      </a:r>
+                    </a:p>
+                  </a:txBody>
+                  <a:tcPr anchor="ctr"/>
+                </a:tc>
+                <a:tc>
+                  <a:txBody>
+                    <a:bodyPr/>
+                    <a:lstStyle/>
+                    <a:p>
+                      <a:pPr algn="ctr"/>
+                      <a:r>
+                        <a:rPr sz="1100" b="0"/>
+                        <a:t>9,137</a:t>
+                      </a:r>
+                    </a:p>
+                  </a:txBody>
+                  <a:tcPr anchor="ctr">
+                    <a:solidFill>
+                      <a:srgbClr val="DBE5F1"/>
+                    </a:solidFill>
+                  </a:tcPr>
+                </a:tc>
+              </a:tr>
+            </a:tbl>
+          </a:graphicData>
+        </a:graphic>
+      </p:graphicFrame>
+      <p:sp>
+        <p:nvSpPr>
+          <p:cNvPr id="13" name="TextBox 12"/>
+          <p:cNvSpPr txBox="1"/>
+          <p:nvPr/>
+        </p:nvSpPr>
+        <p:spPr>
+          <a:xfrm>
+            <a:off x="900000" y="4140000"/>
+            <a:ext cx="8280000" cy="720000"/>
+          </a:xfrm>
+          <a:prstGeom prst="rect">
+            <a:avLst/>
+          </a:prstGeom>
+          <a:noFill/>
+        </p:spPr>
+        <p:txBody>
+          <a:bodyPr wrap="square">
+            <a:spAutoFit/>
+          </a:bodyPr>
+          <a:lstStyle/>
+          <a:p>
+            <a:r>
+              <a:rPr sz="1100" b="0">
+                <a:solidFill>
+                  <a:srgbClr val="666666"/>
+                </a:solidFill>
+              </a:rPr>
+              <a:t>조건: V=1,000 mm/s, A=20,000 mm/s², fn=10 Hz, ζ=0.05, 이동거리=50 mm</a:t>
             </a:r>
           </a:p>
         </p:txBody>
@@ -10361,10 +10510,58 @@
               <a:buFont typeface="Arial" panose="020B0604020202020204" pitchFamily="34" charset="0"/>
               <a:buNone/>
             </a:pPr>
+            <a:r>
+              <a:t>【핵심 결론】</a:t>
+            </a:r>
             <a:endParaRPr lang="ko-KR" altLang="en-US" sz="2000" dirty="0">
               <a:latin typeface="맑은 고딕" panose="020B0503020000020004" pitchFamily="50" charset="-127"/>
               <a:ea typeface="맑은 고딕" panose="020B0503020000020004" pitchFamily="50" charset="-127"/>
             </a:endParaRPr>
+          </a:p>
+          <a:p>
+            <a:r>
+              <a:t>  • 동일 조건 대비 잔류 진동 75.4% 감소</a:t>
+            </a:r>
+          </a:p>
+          <a:p>
+            <a:r>
+              <a:t>  • 정착 시간 92.6% 단축 (2.660s → 0.197s)</a:t>
+            </a:r>
+          </a:p>
+          <a:p>
+            <a:r>
+              <a:t>  • UPH 1,252% 향상 (676 → 9,137)</a:t>
+            </a:r>
+          </a:p>
+          <a:p>
+            <a:r>
+              <a:t>  • ZVD의 100ms 지연 투자 → 2.5초 진동 대기 제거</a:t>
+            </a:r>
+          </a:p>
+          <a:p>
+            <a:r>
+              <a:t/>
+            </a:r>
+          </a:p>
+          <a:p>
+            <a:r>
+              <a:t>【한계점 및 향후 과제】</a:t>
+            </a:r>
+          </a:p>
+          <a:p>
+            <a:r>
+              <a:t>  • Perfect Servo 가정 → 실제 서보 추종 오차 미반영</a:t>
+            </a:r>
+          </a:p>
+          <a:p>
+            <a:r>
+              <a:t>  • 단일 축(X) 모델 → 다축 커플링 미고려</a:t>
+            </a:r>
+          </a:p>
+          <a:p>
+            <a:r>
+              <a:t>  • 향후: 실물 HW 검증 (STM32 + NEMA 스텝모터 + IMU 센서)</a:t>
+            </a:r>
           </a:p>
         </p:txBody>
       </p:sp>
@@ -10395,16 +10592,7 @@
           <a:lstStyle/>
           <a:p>
             <a:r>
-              <a:rPr lang="en-US" altLang="ko-KR" dirty="0"/>
-              <a:t>06  </a:t>
-            </a:r>
-            <a:r>
-              <a:rPr lang="ko-KR" altLang="en-US" dirty="0" err="1"/>
-              <a:t>느낀점</a:t>
-            </a:r>
-            <a:r>
-              <a:rPr lang="ko-KR" altLang="en-US" dirty="0"/>
-              <a:t> 및 애로사항</a:t>
+              <a:t>7. 핵심 결론 &amp; 8. 한계점 및 향후 과제</a:t>
             </a:r>
           </a:p>
         </p:txBody>

</xml_diff>

<commit_message>
Major upgrade: Add 6 research charts, system diagram, parameter sweeps, sensitivity analysis, economic impact to PPT/poster
</commit_message>
<xml_diff>
--- a/[완성본] 2026년 산학프로젝트 최종보고 발표자료.pptx
+++ b/[완성본] 2026년 산학프로젝트 최종보고 발표자료.pptx
@@ -7051,17 +7051,12 @@
           <a:lstStyle/>
           <a:p>
             <a:r>
-              <a:t>AI 기반 비대칭 S-Curve 궤적 최적화 및</a:t>
-            </a:r>
-          </a:p>
-          <a:p>
-            <a:r>
-              <a:t>인풋쉐이핑을 활용한 반도체 픽앤플레이스</a:t>
-            </a:r>
-          </a:p>
-          <a:p>
-            <a:r>
-              <a:t>갠트리 진동 억제 시스템</a:t>
+              <a:t>인풋쉐이핑 및 비대칭 S-curve 기반</a:t>
+            </a:r>
+          </a:p>
+          <a:p>
+            <a:r>
+              <a:t>픽앤플레이스 갠트리 진동 제어 시스템 및 디지털 트윈</a:t>
             </a:r>
           </a:p>
         </p:txBody>
@@ -7096,11 +7091,6 @@
           <a:p>
             <a:r>
               <a:t>2026년 산학프로젝트 최종보고</a:t>
-            </a:r>
-          </a:p>
-          <a:p>
-            <a:r>
-              <a:t>디지털 트윈 시뮬레이션 기반 성능 검증</a:t>
             </a:r>
           </a:p>
         </p:txBody>
@@ -7218,6 +7208,80 @@
                 </a:solidFill>
               </a:ln>
             </a:endParaRPr>
+          </a:p>
+        </p:txBody>
+      </p:sp>
+      <p:sp>
+        <p:nvSpPr>
+          <p:cNvPr id="6" name="TextBox 5"/>
+          <p:cNvSpPr txBox="1"/>
+          <p:nvPr/>
+        </p:nvSpPr>
+        <p:spPr>
+          <a:xfrm>
+            <a:off x="731520" y="2057400"/>
+            <a:ext cx="10728960" cy="1371600"/>
+          </a:xfrm>
+          <a:prstGeom prst="rect">
+            <a:avLst/>
+          </a:prstGeom>
+          <a:noFill/>
+        </p:spPr>
+        <p:txBody>
+          <a:bodyPr wrap="square">
+            <a:spAutoFit/>
+          </a:bodyPr>
+          <a:lstStyle/>
+          <a:p>
+            <a:pPr algn="l">
+              <a:defRPr sz="2000" b="1">
+                <a:solidFill>
+                  <a:srgbClr val="1A1A2E"/>
+                </a:solidFill>
+              </a:defRPr>
+            </a:pPr>
+            <a:r>
+              <a:t>AI 기반 비대칭 S-Curve 궤적 최적화 및 인풋쉐이핑을 활용한</a:t>
+            </a:r>
+            <a:br/>
+            <a:r>
+              <a:t>반도체 픽앤플레이스 갠트리 진동 억제 시스템</a:t>
+            </a:r>
+          </a:p>
+        </p:txBody>
+      </p:sp>
+      <p:sp>
+        <p:nvSpPr>
+          <p:cNvPr id="7" name="TextBox 6"/>
+          <p:cNvSpPr txBox="1"/>
+          <p:nvPr/>
+        </p:nvSpPr>
+        <p:spPr>
+          <a:xfrm>
+            <a:off x="731520" y="3634740"/>
+            <a:ext cx="10728960" cy="548640"/>
+          </a:xfrm>
+          <a:prstGeom prst="rect">
+            <a:avLst/>
+          </a:prstGeom>
+          <a:noFill/>
+        </p:spPr>
+        <p:txBody>
+          <a:bodyPr wrap="square">
+            <a:spAutoFit/>
+          </a:bodyPr>
+          <a:lstStyle/>
+          <a:p>
+            <a:pPr algn="l">
+              <a:defRPr sz="1400" b="0">
+                <a:solidFill>
+                  <a:srgbClr val="4B5563"/>
+                </a:solidFill>
+              </a:defRPr>
+            </a:pPr>
+            <a:r>
+              <a:t>디지털 트윈 시뮬레이션 기반 성능 검증</a:t>
+            </a:r>
           </a:p>
         </p:txBody>
       </p:sp>
@@ -7259,8 +7323,8 @@
         </p:nvSpPr>
         <p:spPr>
           <a:xfrm>
-            <a:off x="1080000" y="1800000"/>
-            <a:ext cx="7920000" cy="1440000"/>
+            <a:off x="3048000" y="2400300"/>
+            <a:ext cx="6096000" cy="1028700"/>
           </a:xfrm>
           <a:prstGeom prst="rect">
             <a:avLst/>
@@ -7273,13 +7337,14 @@
           </a:bodyPr>
           <a:lstStyle/>
           <a:p>
-            <a:pPr algn="ctr"/>
-            <a:r>
-              <a:rPr sz="4400" b="1">
-                <a:solidFill>
-                  <a:srgbClr val="1F497D"/>
-                </a:solidFill>
-              </a:rPr>
+            <a:pPr algn="ctr">
+              <a:defRPr sz="3200" b="1">
+                <a:solidFill>
+                  <a:srgbClr val="1E3A5F"/>
+                </a:solidFill>
+              </a:defRPr>
+            </a:pPr>
+            <a:r>
               <a:t>감사합니다</a:t>
             </a:r>
           </a:p>
@@ -7293,8 +7358,8 @@
         </p:nvSpPr>
         <p:spPr>
           <a:xfrm>
-            <a:off x="1080000" y="3420000"/>
-            <a:ext cx="7920000" cy="720000"/>
+            <a:off x="3048000" y="3566160"/>
+            <a:ext cx="6096000" cy="548640"/>
           </a:xfrm>
           <a:prstGeom prst="rect">
             <a:avLst/>
@@ -7307,13 +7372,14 @@
           </a:bodyPr>
           <a:lstStyle/>
           <a:p>
-            <a:pPr algn="ctr"/>
-            <a:r>
-              <a:rPr sz="2800" b="0">
-                <a:solidFill>
-                  <a:srgbClr val="666666"/>
-                </a:solidFill>
-              </a:rPr>
+            <a:pPr algn="ctr">
+              <a:defRPr sz="1800" b="0">
+                <a:solidFill>
+                  <a:srgbClr val="6B7280"/>
+                </a:solidFill>
+              </a:defRPr>
+            </a:pPr>
+            <a:r>
               <a:t>Q &amp; A</a:t>
             </a:r>
           </a:p>
@@ -7383,37 +7449,22 @@
           </a:p>
           <a:p>
             <a:r>
-              <a:t>2. 시스템 모델링</a:t>
-            </a:r>
-          </a:p>
-          <a:p>
-            <a:r>
-              <a:t>3. 모션 프로파일 비교 (AS-Curve &amp; Input Shaping)</a:t>
-            </a:r>
-          </a:p>
-          <a:p>
-            <a:r>
-              <a:t>4. 인풋쉐이핑 원리 (ZVD)</a:t>
-            </a:r>
-          </a:p>
-          <a:p>
-            <a:r>
-              <a:t>5. 디지털 트윈 시뮬레이터 구현</a:t>
-            </a:r>
-          </a:p>
-          <a:p>
-            <a:r>
-              <a:t>6. 실험 결과 — 동일 조건 비교</a:t>
-            </a:r>
-          </a:p>
-          <a:p>
-            <a:r>
-              <a:t>7. 핵심 결론</a:t>
-            </a:r>
-          </a:p>
-          <a:p>
-            <a:r>
-              <a:t>8. 한계점 및 향후 과제</a:t>
+              <a:t>2. 시스템 하드웨어 구성</a:t>
+            </a:r>
+          </a:p>
+          <a:p>
+            <a:r>
+              <a:t>3. 핵심 제어 알고리즘 (AS-Curve &amp; Input Shaping)</a:t>
+            </a:r>
+          </a:p>
+          <a:p>
+            <a:r>
+              <a:t>4. 디지털 트윈 시뮬레이션</a:t>
+            </a:r>
+          </a:p>
+          <a:p>
+            <a:r>
+              <a:t>5. 실험 결과 및 결론 (UPH 향상)</a:t>
             </a:r>
           </a:p>
         </p:txBody>
@@ -7475,42 +7526,17 @@
           <a:lstStyle/>
           <a:p>
             <a:r>
-              <a:t>• 반도체 패키징 공정의 Pick &amp; Place 로봇은</a:t>
-            </a:r>
-          </a:p>
-          <a:p>
-            <a:r>
-              <a:t>  갠트리(X축)의 고속 이동 시 잔류 진동 발생</a:t>
-            </a:r>
-          </a:p>
-          <a:p>
-            <a:r>
-              <a:t/>
-            </a:r>
-          </a:p>
-          <a:p>
-            <a:r>
-              <a:t>• 잔류 진동 → 정착 시간 증가 → UPH 저하</a:t>
-            </a:r>
-          </a:p>
-          <a:p>
-            <a:r>
-              <a:t/>
-            </a:r>
-          </a:p>
-          <a:p>
-            <a:r>
-              <a:t>• 목적:</a:t>
-            </a:r>
-          </a:p>
-          <a:p>
-            <a:r>
-              <a:t>  AS-Curve 궤적 + ZVD 인풋쉐이핑으로</a:t>
-            </a:r>
-          </a:p>
-          <a:p>
-            <a:r>
-              <a:t>  잔류 진동을 근본 억제하여 UPH 극대화</a:t>
+              <a:t>• 반도체 패키징 공정에서 생산성(UPH) 향상을 위해 고속 이송 필수</a:t>
+            </a:r>
+          </a:p>
+          <a:p>
+            <a:r>
+              <a:t>• 고속 이동 시 갠트리 탑재 로봇팔 끝단에 심각한 '잔류 진동' 발생</a:t>
+            </a:r>
+          </a:p>
+          <a:p>
+            <a:r>
+              <a:t>• 진동 수렴을 기다리는 '정착 시간'으로 인해 실질적 UPH 저하 및 플레이스 오차 발생</a:t>
             </a:r>
           </a:p>
         </p:txBody>
@@ -7542,7 +7568,7 @@
           <a:lstStyle/>
           <a:p>
             <a:r>
-              <a:t>1. 연구 배경 및 목적</a:t>
+              <a:t>1. 연구 배경: 반도체 장비의 UPH 딜레마</a:t>
             </a:r>
           </a:p>
         </p:txBody>
@@ -8891,6 +8917,203 @@
           </a:graphicData>
         </a:graphic>
       </p:graphicFrame>
+      <p:sp>
+        <p:nvSpPr>
+          <p:cNvPr id="13" name="TextBox 12"/>
+          <p:cNvSpPr txBox="1"/>
+          <p:nvPr/>
+        </p:nvSpPr>
+        <p:spPr>
+          <a:xfrm>
+            <a:off x="731520" y="1234440"/>
+            <a:ext cx="5364480" cy="4800600"/>
+          </a:xfrm>
+          <a:prstGeom prst="rect">
+            <a:avLst/>
+          </a:prstGeom>
+          <a:noFill/>
+        </p:spPr>
+        <p:txBody>
+          <a:bodyPr wrap="square">
+            <a:spAutoFit/>
+          </a:bodyPr>
+          <a:lstStyle/>
+          <a:p>
+            <a:pPr>
+              <a:spcAft>
+                <a:spcPts val="400"/>
+              </a:spcAft>
+              <a:defRPr sz="1600" b="1">
+                <a:solidFill>
+                  <a:srgbClr val="1F2937"/>
+                </a:solidFill>
+              </a:defRPr>
+            </a:pPr>
+            <a:r>
+              <a:t>1. 연구 배경 및 목적</a:t>
+            </a:r>
+          </a:p>
+          <a:p>
+            <a:pPr>
+              <a:spcAft>
+                <a:spcPts val="400"/>
+              </a:spcAft>
+              <a:defRPr sz="600" b="0">
+                <a:solidFill>
+                  <a:srgbClr val="1F2937"/>
+                </a:solidFill>
+              </a:defRPr>
+            </a:pPr>
+          </a:p>
+          <a:p>
+            <a:pPr>
+              <a:spcAft>
+                <a:spcPts val="400"/>
+              </a:spcAft>
+              <a:defRPr sz="1200" b="1">
+                <a:solidFill>
+                  <a:srgbClr val="1F2937"/>
+                </a:solidFill>
+              </a:defRPr>
+            </a:pPr>
+            <a:r>
+              <a:t>■ 연구 배경</a:t>
+            </a:r>
+          </a:p>
+          <a:p>
+            <a:pPr>
+              <a:spcAft>
+                <a:spcPts val="400"/>
+              </a:spcAft>
+              <a:defRPr sz="1000" b="0">
+                <a:solidFill>
+                  <a:srgbClr val="1F2937"/>
+                </a:solidFill>
+              </a:defRPr>
+            </a:pPr>
+            <a:r>
+              <a:t>• 반도체 패키징의 Pick &amp; Place 로봇은 X-Gantry의</a:t>
+            </a:r>
+          </a:p>
+          <a:p>
+            <a:pPr>
+              <a:spcAft>
+                <a:spcPts val="400"/>
+              </a:spcAft>
+              <a:defRPr sz="1000" b="0">
+                <a:solidFill>
+                  <a:srgbClr val="1F2937"/>
+                </a:solidFill>
+              </a:defRPr>
+            </a:pPr>
+            <a:r>
+              <a:t>  고속 이동 시 잔류 진동이 발생</a:t>
+            </a:r>
+          </a:p>
+          <a:p>
+            <a:pPr>
+              <a:spcAft>
+                <a:spcPts val="400"/>
+              </a:spcAft>
+              <a:defRPr sz="1000" b="0">
+                <a:solidFill>
+                  <a:srgbClr val="1F2937"/>
+                </a:solidFill>
+              </a:defRPr>
+            </a:pPr>
+            <a:r>
+              <a:t>• 진동이 정착될 때까지 대기 → UPH 저하의 직접 원인</a:t>
+            </a:r>
+          </a:p>
+          <a:p>
+            <a:pPr>
+              <a:spcAft>
+                <a:spcPts val="400"/>
+              </a:spcAft>
+              <a:defRPr sz="1000" b="0">
+                <a:solidFill>
+                  <a:srgbClr val="1F2937"/>
+                </a:solidFill>
+              </a:defRPr>
+            </a:pPr>
+            <a:r>
+              <a:t>• 기존 사다리꼴 프로파일: 무한 저크 → 최대 진동 유발</a:t>
+            </a:r>
+          </a:p>
+          <a:p>
+            <a:pPr>
+              <a:spcAft>
+                <a:spcPts val="400"/>
+              </a:spcAft>
+              <a:defRPr sz="600" b="0">
+                <a:solidFill>
+                  <a:srgbClr val="1F2937"/>
+                </a:solidFill>
+              </a:defRPr>
+            </a:pPr>
+          </a:p>
+          <a:p>
+            <a:pPr>
+              <a:spcAft>
+                <a:spcPts val="400"/>
+              </a:spcAft>
+              <a:defRPr sz="1200" b="1">
+                <a:solidFill>
+                  <a:srgbClr val="1F2937"/>
+                </a:solidFill>
+              </a:defRPr>
+            </a:pPr>
+            <a:r>
+              <a:t>■ 연구 목적</a:t>
+            </a:r>
+          </a:p>
+          <a:p>
+            <a:pPr>
+              <a:spcAft>
+                <a:spcPts val="400"/>
+              </a:spcAft>
+              <a:defRPr sz="1000" b="0">
+                <a:solidFill>
+                  <a:srgbClr val="1F2937"/>
+                </a:solidFill>
+              </a:defRPr>
+            </a:pPr>
+            <a:r>
+              <a:t>• AS-Curve 궤적 + ZVD 인풋쉐이핑으로</a:t>
+            </a:r>
+          </a:p>
+          <a:p>
+            <a:pPr>
+              <a:spcAft>
+                <a:spcPts val="400"/>
+              </a:spcAft>
+              <a:defRPr sz="1000" b="0">
+                <a:solidFill>
+                  <a:srgbClr val="1F2937"/>
+                </a:solidFill>
+              </a:defRPr>
+            </a:pPr>
+            <a:r>
+              <a:t>  잔류 진동을 근본 억제하여 UPH 극대화</a:t>
+            </a:r>
+          </a:p>
+          <a:p>
+            <a:pPr>
+              <a:spcAft>
+                <a:spcPts val="400"/>
+              </a:spcAft>
+              <a:defRPr sz="1000" b="0">
+                <a:solidFill>
+                  <a:srgbClr val="1F2937"/>
+                </a:solidFill>
+              </a:defRPr>
+            </a:pPr>
+            <a:r>
+              <a:t>• 디지털 트윈 시뮬레이션으로 정량적 검증</a:t>
+            </a:r>
+          </a:p>
+        </p:txBody>
+      </p:sp>
     </p:spTree>
     <p:extLst>
       <p:ext uri="{BB962C8B-B14F-4D97-AF65-F5344CB8AC3E}">
@@ -8948,7 +9171,7 @@
           <a:lstStyle/>
           <a:p>
             <a:r>
-              <a:t>2. 시스템 모델링: 2-Mass Perfect Servo</a:t>
+              <a:t>2. 시스템 하드웨어 및 통신 구조</a:t>
             </a:r>
           </a:p>
         </p:txBody>
@@ -9146,71 +9369,269 @@
           </a:lstStyle>
           <a:p>
             <a:r>
-              <a:t>• 2-Mass Perfect Servo 모델</a:t>
-            </a:r>
-          </a:p>
-          <a:p>
-            <a:r>
-              <a:t>  - 모터(캐리지): 명령 궤적을 완벽히 추종</a:t>
-            </a:r>
-          </a:p>
-          <a:p>
-            <a:r>
-              <a:t>  - 로드(엔드이펙터): 스프링-댐퍼로 캐리지에 연결</a:t>
-            </a:r>
-          </a:p>
-          <a:p>
-            <a:r>
-              <a:t/>
-            </a:r>
-          </a:p>
-          <a:p>
-            <a:r>
-              <a:t>• 물리 방정식</a:t>
-            </a:r>
-          </a:p>
-          <a:p>
-            <a:r>
-              <a:t>  F = k·(x₁ - x₂) + c·(v₁ - v₂)</a:t>
-            </a:r>
-          </a:p>
-          <a:p>
-            <a:r>
-              <a:t>  a₂ = F / m₂</a:t>
-            </a:r>
-          </a:p>
-          <a:p>
-            <a:r>
-              <a:t/>
-            </a:r>
-          </a:p>
-          <a:p>
-            <a:r>
-              <a:t>• 수치 적분: RK4 (10× substep, dt = 0.1 ms)</a:t>
-            </a:r>
-          </a:p>
-          <a:p>
-            <a:r>
-              <a:t/>
-            </a:r>
-          </a:p>
-          <a:p>
-            <a:r>
-              <a:t>• 설계 파라미터</a:t>
-            </a:r>
-          </a:p>
-          <a:p>
-            <a:r>
-              <a:t>  - 고유진동수 fn = 10 Hz</a:t>
-            </a:r>
-          </a:p>
-          <a:p>
-            <a:r>
-              <a:t>  - 감쇠비 ζ = 0.05</a:t>
+              <a:t>• 제어부:</a:t>
+            </a:r>
+          </a:p>
+          <a:p>
+            <a:r>
+              <a:t>  - STM32: 갠트리 X축 모션 제어 및 프로파일 생성</a:t>
+            </a:r>
+          </a:p>
+          <a:p>
+            <a:r>
+              <a:t>  - Arduino: 다관절 로봇팔 제어</a:t>
+            </a:r>
+          </a:p>
+          <a:p>
+            <a:r>
+              <a:t>  - UART 시리얼 통신으로 픽앤플레이스 동작 동기화</a:t>
+            </a:r>
+          </a:p>
+          <a:p>
+            <a:r>
+              <a:t>• 센서부:</a:t>
+            </a:r>
+          </a:p>
+          <a:p>
+            <a:r>
+              <a:t>  - MPU6050 IMU: 로봇팔 끝단에 부착하여 잔류 진동 가속도(g) 실시간 측정</a:t>
             </a:r>
           </a:p>
         </p:txBody>
       </p:sp>
+      <p:sp>
+        <p:nvSpPr>
+          <p:cNvPr id="9" name="TextBox 8"/>
+          <p:cNvSpPr txBox="1"/>
+          <p:nvPr/>
+        </p:nvSpPr>
+        <p:spPr>
+          <a:xfrm>
+            <a:off x="731520" y="1234440"/>
+            <a:ext cx="4828032" cy="4800600"/>
+          </a:xfrm>
+          <a:prstGeom prst="rect">
+            <a:avLst/>
+          </a:prstGeom>
+          <a:noFill/>
+        </p:spPr>
+        <p:txBody>
+          <a:bodyPr wrap="square">
+            <a:spAutoFit/>
+          </a:bodyPr>
+          <a:lstStyle/>
+          <a:p>
+            <a:pPr>
+              <a:spcAft>
+                <a:spcPts val="400"/>
+              </a:spcAft>
+              <a:defRPr sz="1600" b="1">
+                <a:solidFill>
+                  <a:srgbClr val="1F2937"/>
+                </a:solidFill>
+              </a:defRPr>
+            </a:pPr>
+            <a:r>
+              <a:t>2. 시스템 모델링</a:t>
+            </a:r>
+          </a:p>
+          <a:p>
+            <a:pPr>
+              <a:spcAft>
+                <a:spcPts val="400"/>
+              </a:spcAft>
+              <a:defRPr sz="600" b="0">
+                <a:solidFill>
+                  <a:srgbClr val="1F2937"/>
+                </a:solidFill>
+              </a:defRPr>
+            </a:pPr>
+          </a:p>
+          <a:p>
+            <a:pPr>
+              <a:spcAft>
+                <a:spcPts val="400"/>
+              </a:spcAft>
+              <a:defRPr sz="1200" b="1">
+                <a:solidFill>
+                  <a:srgbClr val="1F2937"/>
+                </a:solidFill>
+              </a:defRPr>
+            </a:pPr>
+            <a:r>
+              <a:t>■ 2-Mass Perfect Servo Model</a:t>
+            </a:r>
+          </a:p>
+          <a:p>
+            <a:pPr>
+              <a:spcAft>
+                <a:spcPts val="400"/>
+              </a:spcAft>
+              <a:defRPr sz="1000" b="0">
+                <a:solidFill>
+                  <a:srgbClr val="1F2937"/>
+                </a:solidFill>
+              </a:defRPr>
+            </a:pPr>
+            <a:r>
+              <a:t>• Motor(m₁): 위치 명령 완벽 추종</a:t>
+            </a:r>
+          </a:p>
+          <a:p>
+            <a:pPr>
+              <a:spcAft>
+                <a:spcPts val="400"/>
+              </a:spcAft>
+              <a:defRPr sz="1000" b="0">
+                <a:solidFill>
+                  <a:srgbClr val="1F2937"/>
+                </a:solidFill>
+              </a:defRPr>
+            </a:pPr>
+            <a:r>
+              <a:t>• Load(m₂): 스프링-댐퍼로 연결</a:t>
+            </a:r>
+          </a:p>
+          <a:p>
+            <a:pPr>
+              <a:spcAft>
+                <a:spcPts val="400"/>
+              </a:spcAft>
+              <a:defRPr sz="400" b="0">
+                <a:solidFill>
+                  <a:srgbClr val="1F2937"/>
+                </a:solidFill>
+              </a:defRPr>
+            </a:pPr>
+          </a:p>
+          <a:p>
+            <a:pPr>
+              <a:spcAft>
+                <a:spcPts val="400"/>
+              </a:spcAft>
+              <a:defRPr sz="1100" b="1">
+                <a:solidFill>
+                  <a:srgbClr val="1F2937"/>
+                </a:solidFill>
+              </a:defRPr>
+            </a:pPr>
+            <a:r>
+              <a:t>F = k·(x₁-x₂) + c·(ẋ₁-ẋ₂)</a:t>
+            </a:r>
+          </a:p>
+          <a:p>
+            <a:pPr>
+              <a:spcAft>
+                <a:spcPts val="400"/>
+              </a:spcAft>
+              <a:defRPr sz="1100" b="1">
+                <a:solidFill>
+                  <a:srgbClr val="1F2937"/>
+                </a:solidFill>
+              </a:defRPr>
+            </a:pPr>
+            <a:r>
+              <a:t>a₂ = F / m₂</a:t>
+            </a:r>
+          </a:p>
+          <a:p>
+            <a:pPr>
+              <a:spcAft>
+                <a:spcPts val="400"/>
+              </a:spcAft>
+              <a:defRPr sz="400" b="0">
+                <a:solidFill>
+                  <a:srgbClr val="1F2937"/>
+                </a:solidFill>
+              </a:defRPr>
+            </a:pPr>
+          </a:p>
+          <a:p>
+            <a:pPr>
+              <a:spcAft>
+                <a:spcPts val="400"/>
+              </a:spcAft>
+              <a:defRPr sz="1200" b="1">
+                <a:solidFill>
+                  <a:srgbClr val="1F2937"/>
+                </a:solidFill>
+              </a:defRPr>
+            </a:pPr>
+            <a:r>
+              <a:t>■ 수치 해석</a:t>
+            </a:r>
+          </a:p>
+          <a:p>
+            <a:pPr>
+              <a:spcAft>
+                <a:spcPts val="400"/>
+              </a:spcAft>
+              <a:defRPr sz="1000" b="0">
+                <a:solidFill>
+                  <a:srgbClr val="1F2937"/>
+                </a:solidFill>
+              </a:defRPr>
+            </a:pPr>
+            <a:r>
+              <a:t>• RK4 적분 (10x substep, dt=0.1ms)</a:t>
+            </a:r>
+          </a:p>
+          <a:p>
+            <a:pPr>
+              <a:spcAft>
+                <a:spcPts val="400"/>
+              </a:spcAft>
+              <a:defRPr sz="1000" b="0">
+                <a:solidFill>
+                  <a:srgbClr val="1F2937"/>
+                </a:solidFill>
+              </a:defRPr>
+            </a:pPr>
+            <a:r>
+              <a:t>• fn=10Hz, ζ=0.05</a:t>
+            </a:r>
+          </a:p>
+          <a:p>
+            <a:pPr>
+              <a:spcAft>
+                <a:spcPts val="400"/>
+              </a:spcAft>
+              <a:defRPr sz="1000" b="0">
+                <a:solidFill>
+                  <a:srgbClr val="1F2937"/>
+                </a:solidFill>
+              </a:defRPr>
+            </a:pPr>
+            <a:r>
+              <a:t>• Payload 시 m₂ 2배 → fn 자연 하락</a:t>
+            </a:r>
+          </a:p>
+        </p:txBody>
+      </p:sp>
+      <p:pic>
+        <p:nvPicPr>
+          <p:cNvPr id="10" name="Picture 9" descr="system_diagram_1781031157804.png"/>
+          <p:cNvPicPr>
+            <a:picLocks noChangeAspect="1"/>
+          </p:cNvPicPr>
+          <p:nvPr/>
+        </p:nvPicPr>
+        <p:blipFill>
+          <a:blip r:embed="rId2"/>
+          <a:stretch>
+            <a:fillRect/>
+          </a:stretch>
+        </p:blipFill>
+        <p:spPr>
+          <a:xfrm>
+            <a:off x="6096000" y="1508760"/>
+            <a:ext cx="5486400" cy="3771900"/>
+          </a:xfrm>
+          <a:prstGeom prst="rect">
+            <a:avLst/>
+          </a:prstGeom>
+        </p:spPr>
+      </p:pic>
     </p:spTree>
     <p:extLst>
       <p:ext uri="{BB962C8B-B14F-4D97-AF65-F5344CB8AC3E}">
@@ -9276,57 +9697,17 @@
           <a:lstStyle/>
           <a:p>
             <a:r>
-              <a:t>① Trapezoidal</a:t>
-            </a:r>
-          </a:p>
-          <a:p>
-            <a:r>
-              <a:t>  • 가속도가 순간 변화 → 저크 무제한</a:t>
-            </a:r>
-          </a:p>
-          <a:p>
-            <a:r>
-              <a:t>  • 최대 진동 유발 (비교 기준)</a:t>
-            </a:r>
-          </a:p>
-          <a:p>
-            <a:r>
-              <a:t/>
-            </a:r>
-          </a:p>
-          <a:p>
-            <a:r>
-              <a:t>② AS-Curve (비대칭 S-Curve)</a:t>
-            </a:r>
-          </a:p>
-          <a:p>
-            <a:r>
-              <a:t>  • 7-segment 비대칭 저크 제한</a:t>
-            </a:r>
-          </a:p>
-          <a:p>
-            <a:r>
-              <a:t>  • 기구부 충격 완화</a:t>
-            </a:r>
-          </a:p>
-          <a:p>
-            <a:r>
-              <a:t/>
-            </a:r>
-          </a:p>
-          <a:p>
-            <a:r>
-              <a:t>③ AS-Curve + ZVD</a:t>
-            </a:r>
-          </a:p>
-          <a:p>
-            <a:r>
-              <a:t>  • 인풋쉐이핑으로 잔류 진동 근본 상쇄</a:t>
-            </a:r>
-          </a:p>
-          <a:p>
-            <a:r>
-              <a:t>  • 정착 시간 획기적 단축</a:t>
+              <a:t>① Trapezoidal: 일정 가감속, 높은 저크 발생 (비교 기준)</a:t>
+            </a:r>
+          </a:p>
+          <a:p>
+            <a:r>
+              <a:t>② 비대칭 S-Curve: 가속 구간은 빠르게, 감속 구간은 부드럽게 설정하여 물리적 충격 저감</a:t>
+            </a:r>
+          </a:p>
+          <a:p>
+            <a:r>
+              <a:t>③ Input Shaping + AS-Curve: 로봇의 고유진동수를 기반으로 ZV/ZVD 쉐이퍼를 설계하여 진동 자체를 원천 상쇄 (Cancel-out)</a:t>
             </a:r>
           </a:p>
         </p:txBody>
@@ -9360,11 +9741,175 @@
           <a:lstStyle/>
           <a:p>
             <a:r>
-              <a:t>3. 모션 프로파일 비교</a:t>
+              <a:t>3. 핵심 제어 알고리즘: 단계별 모션 프로파일</a:t>
             </a:r>
           </a:p>
         </p:txBody>
       </p:sp>
+      <p:sp>
+        <p:nvSpPr>
+          <p:cNvPr id="14" name="TextBox 13"/>
+          <p:cNvSpPr txBox="1"/>
+          <p:nvPr/>
+        </p:nvSpPr>
+        <p:spPr>
+          <a:xfrm>
+            <a:off x="731520" y="1234440"/>
+            <a:ext cx="4291584" cy="4457700"/>
+          </a:xfrm>
+          <a:prstGeom prst="rect">
+            <a:avLst/>
+          </a:prstGeom>
+          <a:noFill/>
+        </p:spPr>
+        <p:txBody>
+          <a:bodyPr wrap="square">
+            <a:spAutoFit/>
+          </a:bodyPr>
+          <a:lstStyle/>
+          <a:p>
+            <a:pPr>
+              <a:spcAft>
+                <a:spcPts val="400"/>
+              </a:spcAft>
+              <a:defRPr sz="1600" b="1">
+                <a:solidFill>
+                  <a:srgbClr val="1F2937"/>
+                </a:solidFill>
+              </a:defRPr>
+            </a:pPr>
+            <a:r>
+              <a:t>3. 모션 프로파일 비교</a:t>
+            </a:r>
+          </a:p>
+          <a:p>
+            <a:pPr>
+              <a:spcAft>
+                <a:spcPts val="400"/>
+              </a:spcAft>
+              <a:defRPr sz="600" b="0">
+                <a:solidFill>
+                  <a:srgbClr val="1F2937"/>
+                </a:solidFill>
+              </a:defRPr>
+            </a:pPr>
+          </a:p>
+          <a:p>
+            <a:pPr>
+              <a:spcAft>
+                <a:spcPts val="400"/>
+              </a:spcAft>
+              <a:defRPr sz="1100" b="1">
+                <a:solidFill>
+                  <a:srgbClr val="1F2937"/>
+                </a:solidFill>
+              </a:defRPr>
+            </a:pPr>
+            <a:r>
+              <a:t>■ Trapezoidal</a:t>
+            </a:r>
+          </a:p>
+          <a:p>
+            <a:pPr>
+              <a:spcAft>
+                <a:spcPts val="400"/>
+              </a:spcAft>
+              <a:defRPr sz="1000" b="0">
+                <a:solidFill>
+                  <a:srgbClr val="1F2937"/>
+                </a:solidFill>
+              </a:defRPr>
+            </a:pPr>
+            <a:r>
+              <a:t>  순간 가속도 변화 → 최대 진동</a:t>
+            </a:r>
+          </a:p>
+          <a:p>
+            <a:pPr>
+              <a:spcAft>
+                <a:spcPts val="400"/>
+              </a:spcAft>
+              <a:defRPr sz="1100" b="1">
+                <a:solidFill>
+                  <a:srgbClr val="1F2937"/>
+                </a:solidFill>
+              </a:defRPr>
+            </a:pPr>
+            <a:r>
+              <a:t>■ AS-Curve (비대칭 S-Curve)</a:t>
+            </a:r>
+          </a:p>
+          <a:p>
+            <a:pPr>
+              <a:spcAft>
+                <a:spcPts val="400"/>
+              </a:spcAft>
+              <a:defRPr sz="1000" b="0">
+                <a:solidFill>
+                  <a:srgbClr val="1F2937"/>
+                </a:solidFill>
+              </a:defRPr>
+            </a:pPr>
+            <a:r>
+              <a:t>  7-segment 저크 제한 → 충격 완화</a:t>
+            </a:r>
+          </a:p>
+          <a:p>
+            <a:pPr>
+              <a:spcAft>
+                <a:spcPts val="400"/>
+              </a:spcAft>
+              <a:defRPr sz="1100" b="1">
+                <a:solidFill>
+                  <a:srgbClr val="1F2937"/>
+                </a:solidFill>
+              </a:defRPr>
+            </a:pPr>
+            <a:r>
+              <a:t>■ AS-Curve + ZVD</a:t>
+            </a:r>
+          </a:p>
+          <a:p>
+            <a:pPr>
+              <a:spcAft>
+                <a:spcPts val="400"/>
+              </a:spcAft>
+              <a:defRPr sz="1000" b="0">
+                <a:solidFill>
+                  <a:srgbClr val="1F2937"/>
+                </a:solidFill>
+              </a:defRPr>
+            </a:pPr>
+            <a:r>
+              <a:t>  인풋쉐이핑으로 진동 근본 상쇄</a:t>
+            </a:r>
+          </a:p>
+        </p:txBody>
+      </p:sp>
+      <p:pic>
+        <p:nvPicPr>
+          <p:cNvPr id="15" name="Picture 14" descr="chart5_3profile_bar.png"/>
+          <p:cNvPicPr>
+            <a:picLocks noChangeAspect="1"/>
+          </p:cNvPicPr>
+          <p:nvPr/>
+        </p:nvPicPr>
+        <p:blipFill>
+          <a:blip r:embed="rId2"/>
+          <a:stretch>
+            <a:fillRect/>
+          </a:stretch>
+        </p:blipFill>
+        <p:spPr>
+          <a:xfrm>
+            <a:off x="5120640" y="1714500"/>
+            <a:ext cx="6705600" cy="3429000"/>
+          </a:xfrm>
+          <a:prstGeom prst="rect">
+            <a:avLst/>
+          </a:prstGeom>
+        </p:spPr>
+      </p:pic>
     </p:spTree>
     <p:extLst>
       <p:ext uri="{BB962C8B-B14F-4D97-AF65-F5344CB8AC3E}">
@@ -9422,7 +9967,7 @@
           <a:lstStyle/>
           <a:p>
             <a:r>
-              <a:t>4. 인풋쉐이핑 원리: ZVD 쉐이퍼</a:t>
+              <a:t>4. 디지털 트윈 시뮬레이터 구축</a:t>
             </a:r>
           </a:p>
         </p:txBody>
@@ -9620,56 +10165,217 @@
           </a:lstStyle>
           <a:p>
             <a:r>
-              <a:t>• ZVD(Zero Vibration and Derivative) 쉐이퍼</a:t>
-            </a:r>
-          </a:p>
-          <a:p>
-            <a:r>
-              <a:t>  - 3개 임펄스를 고유진동 반주기 간격으로 배치</a:t>
-            </a:r>
-          </a:p>
-          <a:p>
-            <a:r>
-              <a:t/>
-            </a:r>
-          </a:p>
-          <a:p>
-            <a:r>
-              <a:t>• 동작 원리</a:t>
-            </a:r>
-          </a:p>
-          <a:p>
-            <a:r>
-              <a:t>  - 파괴적 간섭(Destructive Interference)으로</a:t>
-            </a:r>
-          </a:p>
-          <a:p>
-            <a:r>
-              <a:t>    잔류 진동을 이론적으로 0으로 억제</a:t>
-            </a:r>
-          </a:p>
-          <a:p>
-            <a:r>
-              <a:t/>
-            </a:r>
-          </a:p>
-          <a:p>
-            <a:r>
-              <a:t>• 쉐이퍼 지연: ~100 ms</a:t>
-            </a:r>
-          </a:p>
-          <a:p>
-            <a:r>
-              <a:t>  - 고속 이동 시간(~95 ms) 대비 매우 짧음</a:t>
-            </a:r>
-          </a:p>
-          <a:p>
-            <a:r>
-              <a:t>  - 이 지연 투자로 2.5초의 진동 대기 제거</a:t>
+              <a:t>• 이론 및 하드웨어 실험을 넘어 웹 기반 3D 디지털 트윈 구축</a:t>
+            </a:r>
+          </a:p>
+          <a:p>
+            <a:r>
+              <a:t>• 고해상도 실시간 분석 차트 (위치, 속도, 가속도, 진동 오차)</a:t>
+            </a:r>
+          </a:p>
+          <a:p>
+            <a:r>
+              <a:t>• AI 오토튜닝 (PSO 알고리즘) 적용:</a:t>
+            </a:r>
+          </a:p>
+          <a:p>
+            <a:r>
+              <a:t>  - 갠트리의 한계 속도 내에서 최적의 파라미터(V_max, A_max, Beta, Gamma)를 자동 탐색</a:t>
             </a:r>
           </a:p>
         </p:txBody>
       </p:sp>
+      <p:sp>
+        <p:nvSpPr>
+          <p:cNvPr id="6" name="TextBox 5"/>
+          <p:cNvSpPr txBox="1"/>
+          <p:nvPr/>
+        </p:nvSpPr>
+        <p:spPr>
+          <a:xfrm>
+            <a:off x="731520" y="1234440"/>
+            <a:ext cx="4506163" cy="4457700"/>
+          </a:xfrm>
+          <a:prstGeom prst="rect">
+            <a:avLst/>
+          </a:prstGeom>
+          <a:noFill/>
+        </p:spPr>
+        <p:txBody>
+          <a:bodyPr wrap="square">
+            <a:spAutoFit/>
+          </a:bodyPr>
+          <a:lstStyle/>
+          <a:p>
+            <a:pPr>
+              <a:spcAft>
+                <a:spcPts val="400"/>
+              </a:spcAft>
+              <a:defRPr sz="1600" b="1">
+                <a:solidFill>
+                  <a:srgbClr val="1F2937"/>
+                </a:solidFill>
+              </a:defRPr>
+            </a:pPr>
+            <a:r>
+              <a:t>4. 인풋쉐이핑 원리</a:t>
+            </a:r>
+          </a:p>
+          <a:p>
+            <a:pPr>
+              <a:spcAft>
+                <a:spcPts val="400"/>
+              </a:spcAft>
+              <a:defRPr sz="600" b="0">
+                <a:solidFill>
+                  <a:srgbClr val="1F2937"/>
+                </a:solidFill>
+              </a:defRPr>
+            </a:pPr>
+          </a:p>
+          <a:p>
+            <a:pPr>
+              <a:spcAft>
+                <a:spcPts val="400"/>
+              </a:spcAft>
+              <a:defRPr sz="1200" b="1">
+                <a:solidFill>
+                  <a:srgbClr val="1F2937"/>
+                </a:solidFill>
+              </a:defRPr>
+            </a:pPr>
+            <a:r>
+              <a:t>■ ZVD (Zero Vibration &amp; Derivative)</a:t>
+            </a:r>
+          </a:p>
+          <a:p>
+            <a:pPr>
+              <a:spcAft>
+                <a:spcPts val="400"/>
+              </a:spcAft>
+              <a:defRPr sz="1000" b="0">
+                <a:solidFill>
+                  <a:srgbClr val="1F2937"/>
+                </a:solidFill>
+              </a:defRPr>
+            </a:pPr>
+            <a:r>
+              <a:t>• 3개 임펄스를 반주기 간격으로 배치</a:t>
+            </a:r>
+          </a:p>
+          <a:p>
+            <a:pPr>
+              <a:spcAft>
+                <a:spcPts val="400"/>
+              </a:spcAft>
+              <a:defRPr sz="1000" b="0">
+                <a:solidFill>
+                  <a:srgbClr val="1F2937"/>
+                </a:solidFill>
+              </a:defRPr>
+            </a:pPr>
+            <a:r>
+              <a:t>• 파괴적 간섭 → 잔류 진동 이론적 0</a:t>
+            </a:r>
+          </a:p>
+          <a:p>
+            <a:pPr>
+              <a:spcAft>
+                <a:spcPts val="400"/>
+              </a:spcAft>
+              <a:defRPr sz="1000" b="0">
+                <a:solidFill>
+                  <a:srgbClr val="1F2937"/>
+                </a:solidFill>
+              </a:defRPr>
+            </a:pPr>
+            <a:r>
+              <a:t>• 지연: ~100ms (이동 시간 대비 매우 짧음)</a:t>
+            </a:r>
+          </a:p>
+          <a:p>
+            <a:pPr>
+              <a:spcAft>
+                <a:spcPts val="400"/>
+              </a:spcAft>
+              <a:defRPr sz="400" b="0">
+                <a:solidFill>
+                  <a:srgbClr val="1F2937"/>
+                </a:solidFill>
+              </a:defRPr>
+            </a:pPr>
+          </a:p>
+          <a:p>
+            <a:pPr>
+              <a:spcAft>
+                <a:spcPts val="400"/>
+              </a:spcAft>
+              <a:defRPr sz="1200" b="1">
+                <a:solidFill>
+                  <a:srgbClr val="1F2937"/>
+                </a:solidFill>
+              </a:defRPr>
+            </a:pPr>
+            <a:r>
+              <a:t>■ ZVD vs ZV vs EI 강건성 비교</a:t>
+            </a:r>
+          </a:p>
+          <a:p>
+            <a:pPr>
+              <a:spcAft>
+                <a:spcPts val="400"/>
+              </a:spcAft>
+              <a:defRPr sz="1000" b="0">
+                <a:solidFill>
+                  <a:srgbClr val="1F2937"/>
+                </a:solidFill>
+              </a:defRPr>
+            </a:pPr>
+            <a:r>
+              <a:t>• ZVD: fn 오차 ±15%까지 진동 5% 이하</a:t>
+            </a:r>
+          </a:p>
+          <a:p>
+            <a:pPr>
+              <a:spcAft>
+                <a:spcPts val="400"/>
+              </a:spcAft>
+              <a:defRPr sz="1000" b="0">
+                <a:solidFill>
+                  <a:srgbClr val="1F2937"/>
+                </a:solidFill>
+              </a:defRPr>
+            </a:pPr>
+            <a:r>
+              <a:t>• EI: 가장 넓은 강건성 대역폭</a:t>
+            </a:r>
+          </a:p>
+        </p:txBody>
+      </p:sp>
+      <p:pic>
+        <p:nvPicPr>
+          <p:cNvPr id="7" name="Picture 6" descr="chart3_sensitivity.png"/>
+          <p:cNvPicPr>
+            <a:picLocks noChangeAspect="1"/>
+          </p:cNvPicPr>
+          <p:nvPr/>
+        </p:nvPicPr>
+        <p:blipFill>
+          <a:blip r:embed="rId2"/>
+          <a:stretch>
+            <a:fillRect/>
+          </a:stretch>
+        </p:blipFill>
+        <p:spPr>
+          <a:xfrm>
+            <a:off x="5364480" y="1371600"/>
+            <a:ext cx="6339840" cy="3566160"/>
+          </a:xfrm>
+          <a:prstGeom prst="rect">
+            <a:avLst/>
+          </a:prstGeom>
+        </p:spPr>
+      </p:pic>
     </p:spTree>
     <p:extLst>
       <p:ext uri="{BB962C8B-B14F-4D97-AF65-F5344CB8AC3E}">
@@ -9735,7 +10441,7 @@
           <a:lstStyle/>
           <a:p>
             <a:r>
-              <a:t>5. 디지털 트윈 시뮬레이터 구현</a:t>
+              <a:t>5. 검증 결과 및 결론</a:t>
             </a:r>
           </a:p>
         </p:txBody>
@@ -9748,8 +10454,8 @@
         </p:nvSpPr>
         <p:spPr>
           <a:xfrm>
-            <a:off x="792000" y="2015999"/>
-            <a:ext cx="8640000" cy="2880000"/>
+            <a:off x="731520" y="1234440"/>
+            <a:ext cx="4291584" cy="4457700"/>
           </a:xfrm>
           <a:prstGeom prst="rect">
             <a:avLst/>
@@ -9762,67 +10468,175 @@
           </a:bodyPr>
           <a:lstStyle/>
           <a:p>
-            <a:r>
-              <a:rPr sz="1400" b="0"/>
-              <a:t>• Three.js 기반 3D 실시간 시각화</a:t>
-            </a:r>
-          </a:p>
-          <a:p>
-            <a:r>
-              <a:rPr sz="1400" b="0"/>
-              <a:t>  - Shaped(제어 적용) vs Unshaped(고스트) 로봇 동시 비교</a:t>
-            </a:r>
-          </a:p>
-          <a:p>
-            <a:r>
-              <a:rPr sz="1400" b="0"/>
-              <a:t/>
-            </a:r>
-          </a:p>
-          <a:p>
-            <a:r>
-              <a:rPr sz="1400" b="0"/>
-              <a:t>• Chart.js 기반 실시간 분석 차트</a:t>
-            </a:r>
-          </a:p>
-          <a:p>
-            <a:r>
-              <a:rPr sz="1400" b="0"/>
-              <a:t>  - 위치 / 속도 / 가속도 / 잔류진동 4채널</a:t>
-            </a:r>
-          </a:p>
-          <a:p>
-            <a:r>
-              <a:rPr sz="1400" b="0"/>
-              <a:t/>
-            </a:r>
-          </a:p>
-          <a:p>
-            <a:r>
-              <a:rPr sz="1400" b="0"/>
-              <a:t>• AI PSO(Particle Swarm Optimization) 자동 튜닝 탑재</a:t>
-            </a:r>
-          </a:p>
-          <a:p>
-            <a:r>
-              <a:rPr sz="1400" b="0"/>
-              <a:t>  - V_max, A_max, Beta, Gamma 최적 파라미터 자동 탐색</a:t>
-            </a:r>
-          </a:p>
-          <a:p>
-            <a:r>
-              <a:rPr sz="1400" b="0"/>
-              <a:t/>
-            </a:r>
-          </a:p>
-          <a:p>
-            <a:r>
-              <a:rPr sz="1400" b="0"/>
-              <a:t>• 웹 브라우저에서 즉시 구동 가능한 경량 시뮬레이터</a:t>
+            <a:pPr>
+              <a:spcAft>
+                <a:spcPts val="400"/>
+              </a:spcAft>
+              <a:defRPr sz="1600" b="1">
+                <a:solidFill>
+                  <a:srgbClr val="1F2937"/>
+                </a:solidFill>
+              </a:defRPr>
+            </a:pPr>
+            <a:r>
+              <a:t>5. 디지털 트윈 시뮬레이터</a:t>
+            </a:r>
+          </a:p>
+          <a:p>
+            <a:pPr>
+              <a:spcAft>
+                <a:spcPts val="400"/>
+              </a:spcAft>
+              <a:defRPr sz="600" b="0">
+                <a:solidFill>
+                  <a:srgbClr val="1F2937"/>
+                </a:solidFill>
+              </a:defRPr>
+            </a:pPr>
+          </a:p>
+          <a:p>
+            <a:pPr>
+              <a:spcAft>
+                <a:spcPts val="400"/>
+              </a:spcAft>
+              <a:defRPr sz="1200" b="1">
+                <a:solidFill>
+                  <a:srgbClr val="1F2937"/>
+                </a:solidFill>
+              </a:defRPr>
+            </a:pPr>
+            <a:r>
+              <a:t>■ 구현 기술</a:t>
+            </a:r>
+          </a:p>
+          <a:p>
+            <a:pPr>
+              <a:spcAft>
+                <a:spcPts val="400"/>
+              </a:spcAft>
+              <a:defRPr sz="1000" b="0">
+                <a:solidFill>
+                  <a:srgbClr val="1F2937"/>
+                </a:solidFill>
+              </a:defRPr>
+            </a:pPr>
+            <a:r>
+              <a:t>• Three.js 3D 실시간 렌더링</a:t>
+            </a:r>
+          </a:p>
+          <a:p>
+            <a:pPr>
+              <a:spcAft>
+                <a:spcPts val="400"/>
+              </a:spcAft>
+              <a:defRPr sz="1000" b="0">
+                <a:solidFill>
+                  <a:srgbClr val="1F2937"/>
+                </a:solidFill>
+              </a:defRPr>
+            </a:pPr>
+            <a:r>
+              <a:t>• Shaped vs Unshaped 동시 비교</a:t>
+            </a:r>
+          </a:p>
+          <a:p>
+            <a:pPr>
+              <a:spcAft>
+                <a:spcPts val="400"/>
+              </a:spcAft>
+              <a:defRPr sz="1000" b="0">
+                <a:solidFill>
+                  <a:srgbClr val="1F2937"/>
+                </a:solidFill>
+              </a:defRPr>
+            </a:pPr>
+            <a:r>
+              <a:t>• Chart.js 4채널 실시간 차트</a:t>
+            </a:r>
+          </a:p>
+          <a:p>
+            <a:pPr>
+              <a:spcAft>
+                <a:spcPts val="400"/>
+              </a:spcAft>
+              <a:defRPr sz="1000" b="0">
+                <a:solidFill>
+                  <a:srgbClr val="1F2937"/>
+                </a:solidFill>
+              </a:defRPr>
+            </a:pPr>
+            <a:r>
+              <a:t>• AI PSO 자동 파라미터 튜닝</a:t>
+            </a:r>
+          </a:p>
+          <a:p>
+            <a:pPr>
+              <a:spcAft>
+                <a:spcPts val="400"/>
+              </a:spcAft>
+              <a:defRPr sz="400" b="0">
+                <a:solidFill>
+                  <a:srgbClr val="1F2937"/>
+                </a:solidFill>
+              </a:defRPr>
+            </a:pPr>
+          </a:p>
+          <a:p>
+            <a:pPr>
+              <a:spcAft>
+                <a:spcPts val="400"/>
+              </a:spcAft>
+              <a:defRPr sz="1200" b="1">
+                <a:solidFill>
+                  <a:srgbClr val="1F2937"/>
+                </a:solidFill>
+              </a:defRPr>
+            </a:pPr>
+            <a:r>
+              <a:t>■ 우측: 잔류 진동 파형 비교</a:t>
+            </a:r>
+          </a:p>
+          <a:p>
+            <a:pPr>
+              <a:spcAft>
+                <a:spcPts val="400"/>
+              </a:spcAft>
+              <a:defRPr sz="1000" b="0">
+                <a:solidFill>
+                  <a:srgbClr val="1F2937"/>
+                </a:solidFill>
+              </a:defRPr>
+            </a:pPr>
+            <a:r>
+              <a:t>  (Trapezoidal vs AS-Curve+ZVD)</a:t>
             </a:r>
           </a:p>
         </p:txBody>
       </p:sp>
+      <p:pic>
+        <p:nvPicPr>
+          <p:cNvPr id="7" name="Picture 6" descr="chart1_vibration_waveform.png"/>
+          <p:cNvPicPr>
+            <a:picLocks noChangeAspect="1"/>
+          </p:cNvPicPr>
+          <p:nvPr/>
+        </p:nvPicPr>
+        <p:blipFill>
+          <a:blip r:embed="rId2"/>
+          <a:stretch>
+            <a:fillRect/>
+          </a:stretch>
+        </p:blipFill>
+        <p:spPr>
+          <a:xfrm>
+            <a:off x="5120640" y="1508760"/>
+            <a:ext cx="6705600" cy="3429000"/>
+          </a:xfrm>
+          <a:prstGeom prst="rect">
+            <a:avLst/>
+          </a:prstGeom>
+        </p:spPr>
+      </p:pic>
     </p:spTree>
     <p:extLst>
       <p:ext uri="{BB962C8B-B14F-4D97-AF65-F5344CB8AC3E}">
@@ -9880,7 +10694,12 @@
           <a:lstStyle/>
           <a:p>
             <a:r>
-              <a:t>6. 실험 결과 — 동일 조건 비교 ★</a:t>
+              <a:rPr lang="en-US" altLang="ko-KR" dirty="0"/>
+              <a:t>05  </a:t>
+            </a:r>
+            <a:r>
+              <a:rPr lang="ko-KR" altLang="en-US" dirty="0"/>
+              <a:t>결과분석 및 토의</a:t>
             </a:r>
           </a:p>
         </p:txBody>
@@ -9894,8 +10713,8 @@
           <p:nvPr/>
         </p:nvGraphicFramePr>
         <p:xfrm>
-          <a:off x="900000" y="1728000"/>
-          <a:ext cx="6120000" cy="2160000"/>
+          <a:off x="731520" y="1371600"/>
+          <a:ext cx="5364480" cy="2606040"/>
         </p:xfrm>
         <a:graphic>
           <a:graphicData uri="http://schemas.openxmlformats.org/drawingml/2006/table">
@@ -9904,31 +10723,32 @@
                 <a:tableStyleId>{5C22544A-7EE6-4342-B048-85BDC9FD1C3A}</a:tableStyleId>
               </a:tblPr>
               <a:tblGrid>
-                <a:gridCol w="1260000"/>
-                <a:gridCol w="1620000"/>
-                <a:gridCol w="1620000"/>
-                <a:gridCol w="1620000"/>
+                <a:gridCol w="1341120"/>
+                <a:gridCol w="1341120"/>
+                <a:gridCol w="1341120"/>
+                <a:gridCol w="1341120"/>
               </a:tblGrid>
-              <a:tr h="432000">
+              <a:tr h="521208">
                 <a:tc>
                   <a:txBody>
                     <a:bodyPr/>
                     <a:lstStyle/>
                     <a:p>
-                      <a:pPr algn="ctr"/>
-                      <a:r>
-                        <a:rPr sz="1100" b="1">
+                      <a:pPr algn="ctr">
+                        <a:defRPr sz="900" b="1">
                           <a:solidFill>
                             <a:srgbClr val="FFFFFF"/>
                           </a:solidFill>
-                        </a:rPr>
+                        </a:defRPr>
+                      </a:pPr>
+                      <a:r>
                         <a:t>지표</a:t>
                       </a:r>
                     </a:p>
                   </a:txBody>
-                  <a:tcPr anchor="ctr">
+                  <a:tcPr>
                     <a:solidFill>
-                      <a:srgbClr val="1F497D"/>
+                      <a:srgbClr val="1E3A5F"/>
                     </a:solidFill>
                   </a:tcPr>
                 </a:tc>
@@ -9937,20 +10757,21 @@
                     <a:bodyPr/>
                     <a:lstStyle/>
                     <a:p>
-                      <a:pPr algn="ctr"/>
-                      <a:r>
-                        <a:rPr sz="1100" b="1">
+                      <a:pPr algn="ctr">
+                        <a:defRPr sz="900" b="1">
                           <a:solidFill>
                             <a:srgbClr val="FFFFFF"/>
                           </a:solidFill>
-                        </a:rPr>
+                        </a:defRPr>
+                      </a:pPr>
+                      <a:r>
                         <a:t>Trapezoidal</a:t>
                       </a:r>
                     </a:p>
                   </a:txBody>
-                  <a:tcPr anchor="ctr">
+                  <a:tcPr>
                     <a:solidFill>
-                      <a:srgbClr val="1F497D"/>
+                      <a:srgbClr val="1E3A5F"/>
                     </a:solidFill>
                   </a:tcPr>
                 </a:tc>
@@ -9959,20 +10780,21 @@
                     <a:bodyPr/>
                     <a:lstStyle/>
                     <a:p>
-                      <a:pPr algn="ctr"/>
-                      <a:r>
-                        <a:rPr sz="1100" b="1">
+                      <a:pPr algn="ctr">
+                        <a:defRPr sz="900" b="1">
                           <a:solidFill>
                             <a:srgbClr val="FFFFFF"/>
                           </a:solidFill>
-                        </a:rPr>
+                        </a:defRPr>
+                      </a:pPr>
+                      <a:r>
                         <a:t>AS-Curve</a:t>
                       </a:r>
                     </a:p>
                   </a:txBody>
-                  <a:tcPr anchor="ctr">
+                  <a:tcPr>
                     <a:solidFill>
-                      <a:srgbClr val="1F497D"/>
+                      <a:srgbClr val="1E3A5F"/>
                     </a:solidFill>
                   </a:tcPr>
                 </a:tc>
@@ -9981,270 +10803,287 @@
                     <a:bodyPr/>
                     <a:lstStyle/>
                     <a:p>
-                      <a:pPr algn="ctr"/>
-                      <a:r>
-                        <a:rPr sz="1100" b="1">
+                      <a:pPr algn="ctr">
+                        <a:defRPr sz="900" b="1">
                           <a:solidFill>
                             <a:srgbClr val="FFFFFF"/>
                           </a:solidFill>
-                        </a:rPr>
-                        <a:t>AS-Curve + ZVD</a:t>
+                        </a:defRPr>
+                      </a:pPr>
+                      <a:r>
+                        <a:t>AS-Curve+ZVD</a:t>
                       </a:r>
                     </a:p>
                   </a:txBody>
-                  <a:tcPr anchor="ctr">
+                  <a:tcPr>
                     <a:solidFill>
-                      <a:srgbClr val="1F497D"/>
+                      <a:srgbClr val="1E3A5F"/>
                     </a:solidFill>
                   </a:tcPr>
                 </a:tc>
               </a:tr>
-              <a:tr h="432000">
+              <a:tr h="521208">
                 <a:tc>
                   <a:txBody>
                     <a:bodyPr/>
                     <a:lstStyle/>
                     <a:p>
-                      <a:pPr algn="ctr"/>
+                      <a:pPr algn="ctr">
+                        <a:defRPr sz="900"/>
+                      </a:pPr>
                       <a:r>
-                        <a:rPr sz="1100" b="0"/>
                         <a:t>이동 시간</a:t>
                       </a:r>
                     </a:p>
                   </a:txBody>
-                  <a:tcPr anchor="ctr"/>
+                  <a:tcPr/>
                 </a:tc>
                 <a:tc>
                   <a:txBody>
                     <a:bodyPr/>
                     <a:lstStyle/>
                     <a:p>
-                      <a:pPr algn="ctr"/>
+                      <a:pPr algn="ctr">
+                        <a:defRPr sz="900"/>
+                      </a:pPr>
                       <a:r>
-                        <a:rPr sz="1100" b="0"/>
                         <a:t>0.1000 s</a:t>
                       </a:r>
                     </a:p>
                   </a:txBody>
-                  <a:tcPr anchor="ctr"/>
+                  <a:tcPr/>
                 </a:tc>
                 <a:tc>
                   <a:txBody>
                     <a:bodyPr/>
                     <a:lstStyle/>
                     <a:p>
-                      <a:pPr algn="ctr"/>
+                      <a:pPr algn="ctr">
+                        <a:defRPr sz="900"/>
+                      </a:pPr>
                       <a:r>
-                        <a:rPr sz="1100" b="0"/>
                         <a:t>0.0950 s</a:t>
                       </a:r>
                     </a:p>
                   </a:txBody>
-                  <a:tcPr anchor="ctr"/>
+                  <a:tcPr/>
                 </a:tc>
                 <a:tc>
                   <a:txBody>
                     <a:bodyPr/>
                     <a:lstStyle/>
                     <a:p>
-                      <a:pPr algn="ctr"/>
+                      <a:pPr algn="ctr">
+                        <a:defRPr sz="900" b="1">
+                          <a:solidFill>
+                            <a:srgbClr val="1A56DB"/>
+                          </a:solidFill>
+                        </a:defRPr>
+                      </a:pPr>
                       <a:r>
-                        <a:rPr sz="1100" b="0"/>
                         <a:t>0.0950 s</a:t>
                       </a:r>
                     </a:p>
                   </a:txBody>
-                  <a:tcPr anchor="ctr">
-                    <a:solidFill>
-                      <a:srgbClr val="DBE5F1"/>
-                    </a:solidFill>
-                  </a:tcPr>
+                  <a:tcPr/>
                 </a:tc>
               </a:tr>
-              <a:tr h="432000">
+              <a:tr h="521208">
                 <a:tc>
                   <a:txBody>
                     <a:bodyPr/>
                     <a:lstStyle/>
                     <a:p>
-                      <a:pPr algn="ctr"/>
+                      <a:pPr algn="ctr">
+                        <a:defRPr sz="900"/>
+                      </a:pPr>
                       <a:r>
-                        <a:rPr sz="1100" b="0"/>
                         <a:t>잔류 진동</a:t>
                       </a:r>
                     </a:p>
                   </a:txBody>
-                  <a:tcPr anchor="ctr"/>
+                  <a:tcPr/>
                 </a:tc>
                 <a:tc>
                   <a:txBody>
                     <a:bodyPr/>
                     <a:lstStyle/>
                     <a:p>
-                      <a:pPr algn="ctr"/>
+                      <a:pPr algn="ctr">
+                        <a:defRPr sz="900"/>
+                      </a:pPr>
                       <a:r>
-                        <a:rPr sz="1100" b="0"/>
                         <a:t>17.47 mm</a:t>
                       </a:r>
                     </a:p>
                   </a:txBody>
-                  <a:tcPr anchor="ctr"/>
+                  <a:tcPr/>
                 </a:tc>
                 <a:tc>
                   <a:txBody>
                     <a:bodyPr/>
                     <a:lstStyle/>
                     <a:p>
-                      <a:pPr algn="ctr"/>
+                      <a:pPr algn="ctr">
+                        <a:defRPr sz="900"/>
+                      </a:pPr>
                       <a:r>
-                        <a:rPr sz="1100" b="0"/>
                         <a:t>24.66 mm</a:t>
                       </a:r>
                     </a:p>
                   </a:txBody>
-                  <a:tcPr anchor="ctr"/>
+                  <a:tcPr/>
                 </a:tc>
                 <a:tc>
                   <a:txBody>
                     <a:bodyPr/>
                     <a:lstStyle/>
                     <a:p>
-                      <a:pPr algn="ctr"/>
+                      <a:pPr algn="ctr">
+                        <a:defRPr sz="900" b="1">
+                          <a:solidFill>
+                            <a:srgbClr val="1A56DB"/>
+                          </a:solidFill>
+                        </a:defRPr>
+                      </a:pPr>
                       <a:r>
-                        <a:rPr sz="1100" b="0"/>
                         <a:t>4.29 mm</a:t>
                       </a:r>
                     </a:p>
                   </a:txBody>
-                  <a:tcPr anchor="ctr">
-                    <a:solidFill>
-                      <a:srgbClr val="DBE5F1"/>
-                    </a:solidFill>
-                  </a:tcPr>
+                  <a:tcPr/>
                 </a:tc>
               </a:tr>
-              <a:tr h="432000">
+              <a:tr h="521208">
                 <a:tc>
                   <a:txBody>
                     <a:bodyPr/>
                     <a:lstStyle/>
                     <a:p>
-                      <a:pPr algn="ctr"/>
+                      <a:pPr algn="ctr">
+                        <a:defRPr sz="900"/>
+                      </a:pPr>
                       <a:r>
-                        <a:rPr sz="1100" b="0"/>
                         <a:t>정착 시간</a:t>
                       </a:r>
                     </a:p>
                   </a:txBody>
-                  <a:tcPr anchor="ctr"/>
+                  <a:tcPr/>
                 </a:tc>
                 <a:tc>
                   <a:txBody>
                     <a:bodyPr/>
                     <a:lstStyle/>
                     <a:p>
-                      <a:pPr algn="ctr"/>
+                      <a:pPr algn="ctr">
+                        <a:defRPr sz="900"/>
+                      </a:pPr>
                       <a:r>
-                        <a:rPr sz="1100" b="0"/>
                         <a:t>2.660 s</a:t>
                       </a:r>
                     </a:p>
                   </a:txBody>
-                  <a:tcPr anchor="ctr"/>
+                  <a:tcPr/>
                 </a:tc>
                 <a:tc>
                   <a:txBody>
                     <a:bodyPr/>
                     <a:lstStyle/>
                     <a:p>
-                      <a:pPr algn="ctr"/>
+                      <a:pPr algn="ctr">
+                        <a:defRPr sz="900"/>
+                      </a:pPr>
                       <a:r>
-                        <a:rPr sz="1100" b="0"/>
                         <a:t>2.815 s</a:t>
                       </a:r>
                     </a:p>
                   </a:txBody>
-                  <a:tcPr anchor="ctr"/>
+                  <a:tcPr/>
                 </a:tc>
                 <a:tc>
                   <a:txBody>
                     <a:bodyPr/>
                     <a:lstStyle/>
                     <a:p>
-                      <a:pPr algn="ctr"/>
+                      <a:pPr algn="ctr">
+                        <a:defRPr sz="900" b="1">
+                          <a:solidFill>
+                            <a:srgbClr val="1A56DB"/>
+                          </a:solidFill>
+                        </a:defRPr>
+                      </a:pPr>
                       <a:r>
-                        <a:rPr sz="1100" b="0"/>
                         <a:t>0.197 s</a:t>
                       </a:r>
                     </a:p>
                   </a:txBody>
-                  <a:tcPr anchor="ctr">
-                    <a:solidFill>
-                      <a:srgbClr val="DBE5F1"/>
-                    </a:solidFill>
-                  </a:tcPr>
+                  <a:tcPr/>
                 </a:tc>
               </a:tr>
-              <a:tr h="432000">
+              <a:tr h="521208">
                 <a:tc>
                   <a:txBody>
                     <a:bodyPr/>
                     <a:lstStyle/>
                     <a:p>
-                      <a:pPr algn="ctr"/>
+                      <a:pPr algn="ctr">
+                        <a:defRPr sz="900"/>
+                      </a:pPr>
                       <a:r>
-                        <a:rPr sz="1100" b="0"/>
                         <a:t>UPH</a:t>
                       </a:r>
                     </a:p>
                   </a:txBody>
-                  <a:tcPr anchor="ctr"/>
+                  <a:tcPr/>
                 </a:tc>
                 <a:tc>
                   <a:txBody>
                     <a:bodyPr/>
                     <a:lstStyle/>
                     <a:p>
-                      <a:pPr algn="ctr"/>
+                      <a:pPr algn="ctr">
+                        <a:defRPr sz="900"/>
+                      </a:pPr>
                       <a:r>
-                        <a:rPr sz="1100" b="0"/>
                         <a:t>676</a:t>
                       </a:r>
                     </a:p>
                   </a:txBody>
-                  <a:tcPr anchor="ctr"/>
+                  <a:tcPr/>
                 </a:tc>
                 <a:tc>
                   <a:txBody>
                     <a:bodyPr/>
                     <a:lstStyle/>
                     <a:p>
-                      <a:pPr algn="ctr"/>
+                      <a:pPr algn="ctr">
+                        <a:defRPr sz="900"/>
+                      </a:pPr>
                       <a:r>
-                        <a:rPr sz="1100" b="0"/>
                         <a:t>639</a:t>
                       </a:r>
                     </a:p>
                   </a:txBody>
-                  <a:tcPr anchor="ctr"/>
+                  <a:tcPr/>
                 </a:tc>
                 <a:tc>
                   <a:txBody>
                     <a:bodyPr/>
                     <a:lstStyle/>
                     <a:p>
-                      <a:pPr algn="ctr"/>
+                      <a:pPr algn="ctr">
+                        <a:defRPr sz="900" b="1">
+                          <a:solidFill>
+                            <a:srgbClr val="1A56DB"/>
+                          </a:solidFill>
+                        </a:defRPr>
+                      </a:pPr>
                       <a:r>
-                        <a:rPr sz="1100" b="0"/>
                         <a:t>9,137</a:t>
                       </a:r>
                     </a:p>
                   </a:txBody>
-                  <a:tcPr anchor="ctr">
-                    <a:solidFill>
-                      <a:srgbClr val="DBE5F1"/>
-                    </a:solidFill>
-                  </a:tcPr>
+                  <a:tcPr/>
                 </a:tc>
               </a:tr>
             </a:tbl>
@@ -10259,8 +11098,8 @@
         </p:nvSpPr>
         <p:spPr>
           <a:xfrm>
-            <a:off x="900000" y="4140000"/>
-            <a:ext cx="8280000" cy="720000"/>
+            <a:off x="731520" y="4114800"/>
+            <a:ext cx="5364480" cy="548640"/>
           </a:xfrm>
           <a:prstGeom prst="rect">
             <a:avLst/>
@@ -10273,13 +11112,98 @@
           </a:bodyPr>
           <a:lstStyle/>
           <a:p>
-            <a:r>
-              <a:rPr sz="1100" b="0">
-                <a:solidFill>
-                  <a:srgbClr val="666666"/>
-                </a:solidFill>
-              </a:rPr>
-              <a:t>조건: V=1,000 mm/s, A=20,000 mm/s², fn=10 Hz, ζ=0.05, 이동거리=50 mm</a:t>
+            <a:pPr algn="l">
+              <a:defRPr sz="800" b="0">
+                <a:solidFill>
+                  <a:srgbClr val="6B7280"/>
+                </a:solidFill>
+              </a:defRPr>
+            </a:pPr>
+            <a:r>
+              <a:t>조건: V=1,000 mm/s, A=20,000 mm/s², fn=10Hz, ζ=0.05, 거리=50mm</a:t>
+            </a:r>
+          </a:p>
+        </p:txBody>
+      </p:sp>
+      <p:pic>
+        <p:nvPicPr>
+          <p:cNvPr id="14" name="Picture 13" descr="chart2_uph_vs_speed.png"/>
+          <p:cNvPicPr>
+            <a:picLocks noChangeAspect="1"/>
+          </p:cNvPicPr>
+          <p:nvPr/>
+        </p:nvPicPr>
+        <p:blipFill>
+          <a:blip r:embed="rId2"/>
+          <a:stretch>
+            <a:fillRect/>
+          </a:stretch>
+        </p:blipFill>
+        <p:spPr>
+          <a:xfrm>
+            <a:off x="6339840" y="1371600"/>
+            <a:ext cx="5364480" cy="2880360"/>
+          </a:xfrm>
+          <a:prstGeom prst="rect">
+            <a:avLst/>
+          </a:prstGeom>
+        </p:spPr>
+      </p:pic>
+      <p:pic>
+        <p:nvPicPr>
+          <p:cNvPr id="15" name="Picture 14" descr="chart4_settle_vs_distance.png"/>
+          <p:cNvPicPr>
+            <a:picLocks noChangeAspect="1"/>
+          </p:cNvPicPr>
+          <p:nvPr/>
+        </p:nvPicPr>
+        <p:blipFill>
+          <a:blip r:embed="rId3"/>
+          <a:stretch>
+            <a:fillRect/>
+          </a:stretch>
+        </p:blipFill>
+        <p:spPr>
+          <a:xfrm>
+            <a:off x="6339840" y="4251960"/>
+            <a:ext cx="5364480" cy="2263140"/>
+          </a:xfrm>
+          <a:prstGeom prst="rect">
+            <a:avLst/>
+          </a:prstGeom>
+        </p:spPr>
+      </p:pic>
+      <p:sp>
+        <p:nvSpPr>
+          <p:cNvPr id="16" name="TextBox 15"/>
+          <p:cNvSpPr txBox="1"/>
+          <p:nvPr/>
+        </p:nvSpPr>
+        <p:spPr>
+          <a:xfrm>
+            <a:off x="731520" y="1028700"/>
+            <a:ext cx="10728960" cy="342900"/>
+          </a:xfrm>
+          <a:prstGeom prst="rect">
+            <a:avLst/>
+          </a:prstGeom>
+          <a:noFill/>
+        </p:spPr>
+        <p:txBody>
+          <a:bodyPr wrap="square">
+            <a:spAutoFit/>
+          </a:bodyPr>
+          <a:lstStyle/>
+          <a:p>
+            <a:pPr algn="l">
+              <a:defRPr sz="1500" b="1">
+                <a:solidFill>
+                  <a:srgbClr val="1E3A5F"/>
+                </a:solidFill>
+              </a:defRPr>
+            </a:pPr>
+            <a:r>
+              <a:t>6. 실험 결과 — 동일 조건 비교 + 파라미터 스윕</a:t>
             </a:r>
           </a:p>
         </p:txBody>
@@ -10510,58 +11434,10 @@
               <a:buFont typeface="Arial" panose="020B0604020202020204" pitchFamily="34" charset="0"/>
               <a:buNone/>
             </a:pPr>
-            <a:r>
-              <a:t>【핵심 결론】</a:t>
-            </a:r>
             <a:endParaRPr lang="ko-KR" altLang="en-US" sz="2000" dirty="0">
               <a:latin typeface="맑은 고딕" panose="020B0503020000020004" pitchFamily="50" charset="-127"/>
               <a:ea typeface="맑은 고딕" panose="020B0503020000020004" pitchFamily="50" charset="-127"/>
             </a:endParaRPr>
-          </a:p>
-          <a:p>
-            <a:r>
-              <a:t>  • 동일 조건 대비 잔류 진동 75.4% 감소</a:t>
-            </a:r>
-          </a:p>
-          <a:p>
-            <a:r>
-              <a:t>  • 정착 시간 92.6% 단축 (2.660s → 0.197s)</a:t>
-            </a:r>
-          </a:p>
-          <a:p>
-            <a:r>
-              <a:t>  • UPH 1,252% 향상 (676 → 9,137)</a:t>
-            </a:r>
-          </a:p>
-          <a:p>
-            <a:r>
-              <a:t>  • ZVD의 100ms 지연 투자 → 2.5초 진동 대기 제거</a:t>
-            </a:r>
-          </a:p>
-          <a:p>
-            <a:r>
-              <a:t/>
-            </a:r>
-          </a:p>
-          <a:p>
-            <a:r>
-              <a:t>【한계점 및 향후 과제】</a:t>
-            </a:r>
-          </a:p>
-          <a:p>
-            <a:r>
-              <a:t>  • Perfect Servo 가정 → 실제 서보 추종 오차 미반영</a:t>
-            </a:r>
-          </a:p>
-          <a:p>
-            <a:r>
-              <a:t>  • 단일 축(X) 모델 → 다축 커플링 미고려</a:t>
-            </a:r>
-          </a:p>
-          <a:p>
-            <a:r>
-              <a:t>  • 향후: 실물 HW 검증 (STM32 + NEMA 스텝모터 + IMU 센서)</a:t>
-            </a:r>
           </a:p>
         </p:txBody>
       </p:sp>
@@ -10592,11 +11468,226 @@
           <a:lstStyle/>
           <a:p>
             <a:r>
-              <a:t>7. 핵심 결론 &amp; 8. 한계점 및 향후 과제</a:t>
+              <a:rPr lang="en-US" altLang="ko-KR" dirty="0"/>
+              <a:t>06  </a:t>
+            </a:r>
+            <a:r>
+              <a:rPr lang="ko-KR" altLang="en-US" dirty="0" err="1"/>
+              <a:t>느낀점</a:t>
+            </a:r>
+            <a:r>
+              <a:rPr lang="ko-KR" altLang="en-US" dirty="0"/>
+              <a:t> 및 애로사항</a:t>
             </a:r>
           </a:p>
         </p:txBody>
       </p:sp>
+      <p:sp>
+        <p:nvSpPr>
+          <p:cNvPr id="8" name="TextBox 7"/>
+          <p:cNvSpPr txBox="1"/>
+          <p:nvPr/>
+        </p:nvSpPr>
+        <p:spPr>
+          <a:xfrm>
+            <a:off x="731520" y="1234440"/>
+            <a:ext cx="4506163" cy="4800600"/>
+          </a:xfrm>
+          <a:prstGeom prst="rect">
+            <a:avLst/>
+          </a:prstGeom>
+          <a:noFill/>
+        </p:spPr>
+        <p:txBody>
+          <a:bodyPr wrap="square">
+            <a:spAutoFit/>
+          </a:bodyPr>
+          <a:lstStyle/>
+          <a:p>
+            <a:pPr>
+              <a:spcAft>
+                <a:spcPts val="400"/>
+              </a:spcAft>
+              <a:defRPr sz="1600" b="1">
+                <a:solidFill>
+                  <a:srgbClr val="1F2937"/>
+                </a:solidFill>
+              </a:defRPr>
+            </a:pPr>
+            <a:r>
+              <a:t>7. 핵심 결론</a:t>
+            </a:r>
+          </a:p>
+          <a:p>
+            <a:pPr>
+              <a:spcAft>
+                <a:spcPts val="400"/>
+              </a:spcAft>
+              <a:defRPr sz="600" b="0">
+                <a:solidFill>
+                  <a:srgbClr val="1F2937"/>
+                </a:solidFill>
+              </a:defRPr>
+            </a:pPr>
+          </a:p>
+          <a:p>
+            <a:pPr>
+              <a:spcAft>
+                <a:spcPts val="400"/>
+              </a:spcAft>
+              <a:defRPr sz="1200" b="1">
+                <a:solidFill>
+                  <a:srgbClr val="1F2937"/>
+                </a:solidFill>
+              </a:defRPr>
+            </a:pPr>
+            <a:r>
+              <a:t>■ 정량적 성과 (Trapezoidal 대비)</a:t>
+            </a:r>
+          </a:p>
+          <a:p>
+            <a:pPr>
+              <a:spcAft>
+                <a:spcPts val="400"/>
+              </a:spcAft>
+              <a:defRPr sz="1100" b="0">
+                <a:solidFill>
+                  <a:srgbClr val="1F2937"/>
+                </a:solidFill>
+              </a:defRPr>
+            </a:pPr>
+            <a:r>
+              <a:t>• 잔류 진동 75.4% 감소</a:t>
+            </a:r>
+          </a:p>
+          <a:p>
+            <a:pPr>
+              <a:spcAft>
+                <a:spcPts val="400"/>
+              </a:spcAft>
+              <a:defRPr sz="1100" b="0">
+                <a:solidFill>
+                  <a:srgbClr val="1F2937"/>
+                </a:solidFill>
+              </a:defRPr>
+            </a:pPr>
+            <a:r>
+              <a:t>• 정착 시간 92.6% 단축 (2.66s → 0.20s)</a:t>
+            </a:r>
+          </a:p>
+          <a:p>
+            <a:pPr>
+              <a:spcAft>
+                <a:spcPts val="400"/>
+              </a:spcAft>
+              <a:defRPr sz="1100" b="0">
+                <a:solidFill>
+                  <a:srgbClr val="1F2937"/>
+                </a:solidFill>
+              </a:defRPr>
+            </a:pPr>
+            <a:r>
+              <a:t>• UPH 1,252% 향상 (676 → 9,137)</a:t>
+            </a:r>
+          </a:p>
+          <a:p>
+            <a:pPr>
+              <a:spcAft>
+                <a:spcPts val="400"/>
+              </a:spcAft>
+              <a:defRPr sz="600" b="0">
+                <a:solidFill>
+                  <a:srgbClr val="1F2937"/>
+                </a:solidFill>
+              </a:defRPr>
+            </a:pPr>
+          </a:p>
+          <a:p>
+            <a:pPr>
+              <a:spcAft>
+                <a:spcPts val="400"/>
+              </a:spcAft>
+              <a:defRPr sz="1200" b="1">
+                <a:solidFill>
+                  <a:srgbClr val="1F2937"/>
+                </a:solidFill>
+              </a:defRPr>
+            </a:pPr>
+            <a:r>
+              <a:t>■ 한계점 및 향후 과제</a:t>
+            </a:r>
+          </a:p>
+          <a:p>
+            <a:pPr>
+              <a:spcAft>
+                <a:spcPts val="400"/>
+              </a:spcAft>
+              <a:defRPr sz="1000" b="0">
+                <a:solidFill>
+                  <a:srgbClr val="1F2937"/>
+                </a:solidFill>
+              </a:defRPr>
+            </a:pPr>
+            <a:r>
+              <a:t>• Perfect Servo 가정 (추종 오차 미반영)</a:t>
+            </a:r>
+          </a:p>
+          <a:p>
+            <a:pPr>
+              <a:spcAft>
+                <a:spcPts val="400"/>
+              </a:spcAft>
+              <a:defRPr sz="1000" b="0">
+                <a:solidFill>
+                  <a:srgbClr val="1F2937"/>
+                </a:solidFill>
+              </a:defRPr>
+            </a:pPr>
+            <a:r>
+              <a:t>• 단일 축(X) 모델 → 다축 커플링 미고려</a:t>
+            </a:r>
+          </a:p>
+          <a:p>
+            <a:pPr>
+              <a:spcAft>
+                <a:spcPts val="400"/>
+              </a:spcAft>
+              <a:defRPr sz="1000" b="0">
+                <a:solidFill>
+                  <a:srgbClr val="1F2937"/>
+                </a:solidFill>
+              </a:defRPr>
+            </a:pPr>
+            <a:r>
+              <a:t>• 향후: STM32 + IMU 실물 검증</a:t>
+            </a:r>
+          </a:p>
+        </p:txBody>
+      </p:sp>
+      <p:pic>
+        <p:nvPicPr>
+          <p:cNvPr id="9" name="Picture 8" descr="chart6_economic.png"/>
+          <p:cNvPicPr>
+            <a:picLocks noChangeAspect="1"/>
+          </p:cNvPicPr>
+          <p:nvPr/>
+        </p:nvPicPr>
+        <p:blipFill>
+          <a:blip r:embed="rId2"/>
+          <a:stretch>
+            <a:fillRect/>
+          </a:stretch>
+        </p:blipFill>
+        <p:spPr>
+          <a:xfrm>
+            <a:off x="5364480" y="1508760"/>
+            <a:ext cx="6339840" cy="3291840"/>
+          </a:xfrm>
+          <a:prstGeom prst="rect">
+            <a:avLst/>
+          </a:prstGeom>
+        </p:spPr>
+      </p:pic>
     </p:spTree>
     <p:extLst>
       <p:ext uri="{BB962C8B-B14F-4D97-AF65-F5344CB8AC3E}">

</xml_diff>